<commit_message>
Add visual workflow slides to drift detection demo deck
Expanded to 9 slides with two workflow visuals: a step-by-step flow
(8 steps in sequence, color-coded by owner — AI / Automated / User)
and a swimlane "who does what" summary showing 6 of 8 steps are
autonomous with only 2 user touch-points.

Co-Authored-By: Claude Opus 4.8 <noreply@anthropic.com>
Claude-Session: https://claude.ai/code/session_01F4JExjQdDmtQgo57VcSgGB
</commit_message>
<xml_diff>
--- a/TCS_Drift_Detection_UseCase.pptx
+++ b/TCS_Drift_Detection_UseCase.pptx
@@ -13,9 +13,10 @@
     <p:sldId id="261" r:id="rId7"/>
     <p:sldId id="262" r:id="rId8"/>
     <p:sldId id="263" r:id="rId9"/>
+    <p:sldId id="264" r:id="rId10"/>
   </p:sldIdLst>
   <p:notesMasterIdLst>
-    <p:notesMasterId r:id="rId10"/>
+    <p:notesMasterId r:id="rId11"/>
   </p:notesMasterIdLst>
   <p:sldSz cx="12192000" cy="6858000"/>
   <p:notesSz cx="6858000" cy="12192000"/>
@@ -1149,6 +1150,94 @@
             <a:fld id="{F7021451-1387-4CA6-816F-3879F97B5CBC}" type="slidenum">
               <a:rPr lang="en-US"/>
               <a:t>8</a:t>
+            </a:fld>
+            <a:endParaRPr lang="en-US"/>
+          </a:p>
+        </p:txBody>
+      </p:sp>
+    </p:spTree>
+    <p:extLst>
+      <p:ext uri="{BB962C8B-B14F-4D97-AF65-F5344CB8AC3E}">
+        <p14:creationId xmlns:p14="http://schemas.microsoft.com/office/powerpoint/2010/main" val="1024086991"/>
+      </p:ext>
+    </p:extLst>
+  </p:cSld>
+  <p:clrMapOvr>
+    <a:masterClrMapping/>
+  </p:clrMapOvr>
+</p:notes>
+</file>
+
+<file path=ppt/notesSlides/notesSlide9.xml><?xml version="1.0" encoding="utf-8"?>
+<p:notes xmlns:a="http://schemas.openxmlformats.org/drawingml/2006/main" xmlns:r="http://schemas.openxmlformats.org/officeDocument/2006/relationships" xmlns:p="http://schemas.openxmlformats.org/presentationml/2006/main">
+  <p:cSld>
+    <p:spTree>
+      <p:nvGrpSpPr>
+        <p:cNvPr id="1" name=""/>
+        <p:cNvGrpSpPr/>
+        <p:nvPr/>
+      </p:nvGrpSpPr>
+      <p:grpSpPr>
+        <a:xfrm>
+          <a:off x="0" y="0"/>
+          <a:ext cx="0" cy="0"/>
+          <a:chOff x="0" y="0"/>
+          <a:chExt cx="0" cy="0"/>
+        </a:xfrm>
+      </p:grpSpPr>
+      <p:sp>
+        <p:nvSpPr>
+          <p:cNvPr id="2" name="Slide Image Placeholder 1"/>
+          <p:cNvSpPr>
+            <a:spLocks noGrp="1" noRot="1" noChangeAspect="1"/>
+          </p:cNvSpPr>
+          <p:nvPr>
+            <p:ph type="sldImg"/>
+          </p:nvPr>
+        </p:nvSpPr>
+        <p:spPr/>
+      </p:sp>
+      <p:sp>
+        <p:nvSpPr>
+          <p:cNvPr id="3" name="Notes Placeholder 2"/>
+          <p:cNvSpPr>
+            <a:spLocks noGrp="1"/>
+          </p:cNvSpPr>
+          <p:nvPr>
+            <p:ph type="body" idx="1"/>
+          </p:nvPr>
+        </p:nvSpPr>
+        <p:spPr/>
+        <p:txBody>
+          <a:bodyPr/>
+          <a:lstStyle/>
+          <a:p>
+            <a:r>
+              <a:rPr lang="en-US" dirty="0"/>
+              <a:t/>
+            </a:r>
+            <a:endParaRPr lang="en-US" dirty="0"/>
+          </a:p>
+        </p:txBody>
+      </p:sp>
+      <p:sp>
+        <p:nvSpPr>
+          <p:cNvPr id="4" name="Slide Number Placeholder 3"/>
+          <p:cNvSpPr>
+            <a:spLocks noGrp="1"/>
+          </p:cNvSpPr>
+          <p:nvPr>
+            <p:ph type="sldNum" sz="quarter" idx="10"/>
+          </p:nvPr>
+        </p:nvSpPr>
+        <p:spPr/>
+        <p:txBody>
+          <a:bodyPr/>
+          <a:lstStyle/>
+          <a:p>
+            <a:fld id="{F7021451-1387-4CA6-816F-3879F97B5CBC}" type="slidenum">
+              <a:rPr lang="en-US"/>
+              <a:t>9</a:t>
             </a:fld>
             <a:endParaRPr lang="en-US"/>
           </a:p>
@@ -1637,26 +1726,6 @@
         </p:nvSpPr>
         <p:spPr>
           <a:xfrm>
-            <a:off x="0" y="0"/>
-            <a:ext cx="12188952" cy="6858000"/>
-          </a:xfrm>
-          <a:prstGeom prst="rect">
-            <a:avLst/>
-          </a:prstGeom>
-          <a:solidFill>
-            <a:srgbClr val="1A237E"/>
-          </a:solidFill>
-          <a:ln/>
-        </p:spPr>
-      </p:sp>
-      <p:sp>
-        <p:nvSpPr>
-          <p:cNvPr id="3" name="Shape 1"/>
-          <p:cNvSpPr/>
-          <p:nvPr/>
-        </p:nvSpPr>
-        <p:spPr>
-          <a:xfrm>
             <a:off x="0" y="4572000"/>
             <a:ext cx="12188952" cy="73152"/>
           </a:xfrm>
@@ -1671,7 +1740,7 @@
       </p:sp>
       <p:sp>
         <p:nvSpPr>
-          <p:cNvPr id="4" name="Text 2"/>
+          <p:cNvPr id="3" name="Text 1"/>
           <p:cNvSpPr/>
           <p:nvPr/>
         </p:nvSpPr>
@@ -1710,7 +1779,7 @@
       </p:sp>
       <p:sp>
         <p:nvSpPr>
-          <p:cNvPr id="5" name="Text 3"/>
+          <p:cNvPr id="4" name="Text 2"/>
           <p:cNvSpPr/>
           <p:nvPr/>
         </p:nvSpPr>
@@ -1730,9 +1799,6 @@
           <a:lstStyle/>
           <a:p>
             <a:pPr indent="0" marL="0">
-              <a:lnSpc>
-                <a:spcPct val="100000"/>
-              </a:lnSpc>
               <a:buNone/>
             </a:pPr>
             <a:r>
@@ -1750,9 +1816,6 @@
           </a:p>
           <a:p>
             <a:pPr indent="0" marL="0">
-              <a:lnSpc>
-                <a:spcPct val="100000"/>
-              </a:lnSpc>
               <a:buNone/>
             </a:pPr>
             <a:r>
@@ -1772,7 +1835,7 @@
       </p:sp>
       <p:sp>
         <p:nvSpPr>
-          <p:cNvPr id="6" name="Text 4"/>
+          <p:cNvPr id="5" name="Text 3"/>
           <p:cNvSpPr/>
           <p:nvPr/>
         </p:nvSpPr>
@@ -1811,7 +1874,7 @@
       </p:sp>
       <p:sp>
         <p:nvSpPr>
-          <p:cNvPr id="7" name="Text 5"/>
+          <p:cNvPr id="6" name="Text 4"/>
           <p:cNvSpPr/>
           <p:nvPr/>
         </p:nvSpPr>
@@ -1957,7 +2020,7 @@
         </p:nvSpPr>
         <p:spPr>
           <a:xfrm>
-            <a:off x="548640" y="320040"/>
+            <a:off x="548640" y="292608"/>
             <a:ext cx="10058400" cy="320040"/>
           </a:xfrm>
           <a:prstGeom prst="rect">
@@ -1996,8 +2059,8 @@
         </p:nvSpPr>
         <p:spPr>
           <a:xfrm>
-            <a:off x="548640" y="640080"/>
-            <a:ext cx="10972800" cy="731520"/>
+            <a:off x="548640" y="603504"/>
+            <a:ext cx="10972800" cy="640080"/>
           </a:xfrm>
           <a:prstGeom prst="rect">
             <a:avLst/>
@@ -2013,7 +2076,7 @@
               <a:buNone/>
             </a:pPr>
             <a:r>
-              <a:rPr lang="en-US" sz="2800" b="1" dirty="0">
+              <a:rPr lang="en-US" sz="2700" b="1" dirty="0">
                 <a:solidFill>
                   <a:srgbClr val="1B1B2F"/>
                 </a:solidFill>
@@ -2023,7 +2086,7 @@
               </a:rPr>
               <a:t>Out-of-band changes break production</a:t>
             </a:r>
-            <a:endParaRPr lang="en-US" sz="2800" dirty="0"/>
+            <a:endParaRPr lang="en-US" sz="2700" dirty="0"/>
           </a:p>
         </p:txBody>
       </p:sp>
@@ -2126,7 +2189,7 @@
                 <a:ea typeface="Segoe UI" pitchFamily="34" charset="-122"/>
                 <a:cs typeface="Segoe UI" pitchFamily="34" charset="-120"/>
               </a:rPr>
-              <a:t>of production outages are change-related</a:t>
+              <a:t>of outages are change-related</a:t>
             </a:r>
             <a:endParaRPr lang="en-US" sz="1300" dirty="0"/>
           </a:p>
@@ -2231,7 +2294,7 @@
                 <a:ea typeface="Segoe UI" pitchFamily="34" charset="-122"/>
                 <a:cs typeface="Segoe UI" pitchFamily="34" charset="-120"/>
               </a:rPr>
-              <a:t>of workloads — manual drift tracking can't scale</a:t>
+              <a:t>of workloads — manual tracking can't scale</a:t>
             </a:r>
             <a:endParaRPr lang="en-US" sz="1300" dirty="0"/>
           </a:p>
@@ -2336,7 +2399,7 @@
                 <a:ea typeface="Segoe UI" pitchFamily="34" charset="-122"/>
                 <a:cs typeface="Segoe UI" pitchFamily="34" charset="-120"/>
               </a:rPr>
-              <a:t>before unsanctioned changes are even noticed</a:t>
+              <a:t>before unsanctioned changes are noticed</a:t>
             </a:r>
             <a:endParaRPr lang="en-US" sz="1300" dirty="0"/>
           </a:p>
@@ -2350,7 +2413,7 @@
         </p:nvSpPr>
         <p:spPr>
           <a:xfrm>
-            <a:off x="548640" y="3474720"/>
+            <a:off x="548640" y="3520440"/>
             <a:ext cx="10972800" cy="365760"/>
           </a:xfrm>
           <a:prstGeom prst="rect">
@@ -2389,7 +2452,7 @@
         </p:nvSpPr>
         <p:spPr>
           <a:xfrm>
-            <a:off x="731520" y="3931920"/>
+            <a:off x="731520" y="3977640"/>
             <a:ext cx="10789920" cy="2103120"/>
           </a:xfrm>
           <a:prstGeom prst="rect">
@@ -2540,7 +2603,7 @@
         </p:nvSpPr>
         <p:spPr>
           <a:xfrm>
-            <a:off x="548640" y="320040"/>
+            <a:off x="548640" y="292608"/>
             <a:ext cx="10058400" cy="320040"/>
           </a:xfrm>
           <a:prstGeom prst="rect">
@@ -2579,8 +2642,8 @@
         </p:nvSpPr>
         <p:spPr>
           <a:xfrm>
-            <a:off x="548640" y="640080"/>
-            <a:ext cx="10972800" cy="731520"/>
+            <a:off x="548640" y="603504"/>
+            <a:ext cx="10972800" cy="640080"/>
           </a:xfrm>
           <a:prstGeom prst="rect">
             <a:avLst/>
@@ -2596,7 +2659,7 @@
               <a:buNone/>
             </a:pPr>
             <a:r>
-              <a:rPr lang="en-US" sz="2800" b="1" dirty="0">
+              <a:rPr lang="en-US" sz="2700" b="1" dirty="0">
                 <a:solidFill>
                   <a:srgbClr val="1B1B2F"/>
                 </a:solidFill>
@@ -2606,7 +2669,7 @@
               </a:rPr>
               <a:t>An AI agent that watches, explains &amp; reverts</a:t>
             </a:r>
-            <a:endParaRPr lang="en-US" sz="2800" dirty="0"/>
+            <a:endParaRPr lang="en-US" sz="2700" dirty="0"/>
           </a:p>
         </p:txBody>
       </p:sp>
@@ -2618,7 +2681,7 @@
         </p:nvSpPr>
         <p:spPr>
           <a:xfrm>
-            <a:off x="548640" y="1508760"/>
+            <a:off x="548640" y="1463040"/>
             <a:ext cx="11064240" cy="914400"/>
           </a:xfrm>
           <a:prstGeom prst="rect">
@@ -2660,7 +2723,7 @@
         </p:nvSpPr>
         <p:spPr>
           <a:xfrm>
-            <a:off x="548640" y="2743200"/>
+            <a:off x="548640" y="2651760"/>
             <a:ext cx="2606040" cy="2286000"/>
           </a:xfrm>
           <a:prstGeom prst="roundRect">
@@ -2687,7 +2750,7 @@
         </p:nvSpPr>
         <p:spPr>
           <a:xfrm>
-            <a:off x="548640" y="2743200"/>
+            <a:off x="548640" y="2651760"/>
             <a:ext cx="2606040" cy="548640"/>
           </a:xfrm>
           <a:prstGeom prst="roundRect">
@@ -2709,7 +2772,7 @@
         </p:nvSpPr>
         <p:spPr>
           <a:xfrm>
-            <a:off x="548640" y="2743200"/>
+            <a:off x="548640" y="2651760"/>
             <a:ext cx="2606040" cy="548640"/>
           </a:xfrm>
           <a:prstGeom prst="rect">
@@ -2748,7 +2811,7 @@
         </p:nvSpPr>
         <p:spPr>
           <a:xfrm>
-            <a:off x="731520" y="3474720"/>
+            <a:off x="731520" y="3383280"/>
             <a:ext cx="2240280" cy="1371600"/>
           </a:xfrm>
           <a:prstGeom prst="rect">
@@ -2773,7 +2836,7 @@
                 <a:ea typeface="Segoe UI" pitchFamily="34" charset="-122"/>
                 <a:cs typeface="Segoe UI" pitchFamily="34" charset="-120"/>
               </a:rPr>
-              <a:t>Background agent scans every 1–5 min, comparing live spec vs baseline</a:t>
+              <a:t>Scans every 1–5 min, live spec vs baseline</a:t>
             </a:r>
             <a:endParaRPr lang="en-US" sz="1300" dirty="0"/>
           </a:p>
@@ -2787,7 +2850,7 @@
         </p:nvSpPr>
         <p:spPr>
           <a:xfrm>
-            <a:off x="3383280" y="2743200"/>
+            <a:off x="3383280" y="2651760"/>
             <a:ext cx="2606040" cy="2286000"/>
           </a:xfrm>
           <a:prstGeom prst="roundRect">
@@ -2814,7 +2877,7 @@
         </p:nvSpPr>
         <p:spPr>
           <a:xfrm>
-            <a:off x="3383280" y="2743200"/>
+            <a:off x="3383280" y="2651760"/>
             <a:ext cx="2606040" cy="548640"/>
           </a:xfrm>
           <a:prstGeom prst="roundRect">
@@ -2836,7 +2899,7 @@
         </p:nvSpPr>
         <p:spPr>
           <a:xfrm>
-            <a:off x="3383280" y="2743200"/>
+            <a:off x="3383280" y="2651760"/>
             <a:ext cx="2606040" cy="548640"/>
           </a:xfrm>
           <a:prstGeom prst="rect">
@@ -2875,7 +2938,7 @@
         </p:nvSpPr>
         <p:spPr>
           <a:xfrm>
-            <a:off x="3566160" y="3474720"/>
+            <a:off x="3566160" y="3383280"/>
             <a:ext cx="2240280" cy="1371600"/>
           </a:xfrm>
           <a:prstGeom prst="rect">
@@ -2900,7 +2963,7 @@
                 <a:ea typeface="Segoe UI" pitchFamily="34" charset="-122"/>
                 <a:cs typeface="Segoe UI" pitchFamily="34" charset="-120"/>
               </a:rPr>
-              <a:t>LLM translates raw spec diffs into 'what changed &amp; when' in plain English</a:t>
+              <a:t>LLM turns spec diffs into plain-English 'what &amp; when'</a:t>
             </a:r>
             <a:endParaRPr lang="en-US" sz="1300" dirty="0"/>
           </a:p>
@@ -2914,7 +2977,7 @@
         </p:nvSpPr>
         <p:spPr>
           <a:xfrm>
-            <a:off x="6217920" y="2743200"/>
+            <a:off x="6217920" y="2651760"/>
             <a:ext cx="2606040" cy="2286000"/>
           </a:xfrm>
           <a:prstGeom prst="roundRect">
@@ -2941,7 +3004,7 @@
         </p:nvSpPr>
         <p:spPr>
           <a:xfrm>
-            <a:off x="6217920" y="2743200"/>
+            <a:off x="6217920" y="2651760"/>
             <a:ext cx="2606040" cy="548640"/>
           </a:xfrm>
           <a:prstGeom prst="roundRect">
@@ -2963,7 +3026,7 @@
         </p:nvSpPr>
         <p:spPr>
           <a:xfrm>
-            <a:off x="6217920" y="2743200"/>
+            <a:off x="6217920" y="2651760"/>
             <a:ext cx="2606040" cy="548640"/>
           </a:xfrm>
           <a:prstGeom prst="rect">
@@ -3002,7 +3065,7 @@
         </p:nvSpPr>
         <p:spPr>
           <a:xfrm>
-            <a:off x="6400800" y="3474720"/>
+            <a:off x="6400800" y="3383280"/>
             <a:ext cx="2240280" cy="1371600"/>
           </a:xfrm>
           <a:prstGeom prst="rect">
@@ -3027,7 +3090,7 @@
                 <a:ea typeface="Segoe UI" pitchFamily="34" charset="-122"/>
                 <a:cs typeface="Segoe UI" pitchFamily="34" charset="-120"/>
               </a:rPr>
-              <a:t>One click issues a strategic-merge patch + controlled rolling restart</a:t>
+              <a:t>One click → strategic-merge patch + rolling restart</a:t>
             </a:r>
             <a:endParaRPr lang="en-US" sz="1300" dirty="0"/>
           </a:p>
@@ -3041,7 +3104,7 @@
         </p:nvSpPr>
         <p:spPr>
           <a:xfrm>
-            <a:off x="9052560" y="2743200"/>
+            <a:off x="9052560" y="2651760"/>
             <a:ext cx="2606040" cy="2286000"/>
           </a:xfrm>
           <a:prstGeom prst="roundRect">
@@ -3068,7 +3131,7 @@
         </p:nvSpPr>
         <p:spPr>
           <a:xfrm>
-            <a:off x="9052560" y="2743200"/>
+            <a:off x="9052560" y="2651760"/>
             <a:ext cx="2606040" cy="548640"/>
           </a:xfrm>
           <a:prstGeom prst="roundRect">
@@ -3090,7 +3153,7 @@
         </p:nvSpPr>
         <p:spPr>
           <a:xfrm>
-            <a:off x="9052560" y="2743200"/>
+            <a:off x="9052560" y="2651760"/>
             <a:ext cx="2606040" cy="548640"/>
           </a:xfrm>
           <a:prstGeom prst="rect">
@@ -3129,7 +3192,7 @@
         </p:nvSpPr>
         <p:spPr>
           <a:xfrm>
-            <a:off x="9235440" y="3474720"/>
+            <a:off x="9235440" y="3383280"/>
             <a:ext cx="2240280" cy="1371600"/>
           </a:xfrm>
           <a:prstGeom prst="rect">
@@ -3154,7 +3217,7 @@
                 <a:ea typeface="Segoe UI" pitchFamily="34" charset="-122"/>
                 <a:cs typeface="Segoe UI" pitchFamily="34" charset="-120"/>
               </a:rPr>
-              <a:t>Every drift &amp; rollback auto-logged to a 90-day compliance trail</a:t>
+              <a:t>Every drift &amp; rollback logged for 90 days</a:t>
             </a:r>
             <a:endParaRPr lang="en-US" sz="1300" dirty="0"/>
           </a:p>
@@ -3168,7 +3231,7 @@
         </p:nvSpPr>
         <p:spPr>
           <a:xfrm>
-            <a:off x="548640" y="5303520"/>
+            <a:off x="548640" y="5212080"/>
             <a:ext cx="11064240" cy="457200"/>
           </a:xfrm>
           <a:prstGeom prst="rect">
@@ -3252,7 +3315,7 @@
         </p:nvSpPr>
         <p:spPr>
           <a:xfrm>
-            <a:off x="548640" y="320040"/>
+            <a:off x="548640" y="292608"/>
             <a:ext cx="10058400" cy="320040"/>
           </a:xfrm>
           <a:prstGeom prst="rect">
@@ -3277,7 +3340,7 @@
                 <a:ea typeface="Segoe UI" pitchFamily="34" charset="-122"/>
                 <a:cs typeface="Segoe UI" pitchFamily="34" charset="-120"/>
               </a:rPr>
-              <a:t>HOW IT WORKS</a:t>
+              <a:t>THE WORKFLOW</a:t>
             </a:r>
             <a:endParaRPr lang="en-US" sz="1300" dirty="0"/>
           </a:p>
@@ -3291,8 +3354,8 @@
         </p:nvSpPr>
         <p:spPr>
           <a:xfrm>
-            <a:off x="548640" y="640080"/>
-            <a:ext cx="10972800" cy="731520"/>
+            <a:off x="548640" y="603504"/>
+            <a:ext cx="10972800" cy="640080"/>
           </a:xfrm>
           <a:prstGeom prst="rect">
             <a:avLst/>
@@ -3308,7 +3371,7 @@
               <a:buNone/>
             </a:pPr>
             <a:r>
-              <a:rPr lang="en-US" sz="2800" b="1" dirty="0">
+              <a:rPr lang="en-US" sz="2700" b="1" dirty="0">
                 <a:solidFill>
                   <a:srgbClr val="1B1B2F"/>
                 </a:solidFill>
@@ -3316,25 +3379,127 @@
                 <a:ea typeface="Segoe UI" pitchFamily="34" charset="-122"/>
                 <a:cs typeface="Segoe UI" pitchFamily="34" charset="-120"/>
               </a:rPr>
-              <a:t>End-to-end AI workflow</a:t>
-            </a:r>
-            <a:endParaRPr lang="en-US" sz="2800" dirty="0"/>
+              <a:t>Step by step — and who does each step</a:t>
+            </a:r>
+            <a:endParaRPr lang="en-US" sz="2700" dirty="0"/>
           </a:p>
         </p:txBody>
       </p:sp>
       <p:sp>
         <p:nvSpPr>
-          <p:cNvPr id="5" name="Shape 3"/>
-          <p:cNvSpPr/>
-          <p:nvPr/>
-        </p:nvSpPr>
-        <p:spPr>
-          <a:xfrm>
-            <a:off x="548640" y="1600200"/>
-            <a:ext cx="640080" cy="640080"/>
-          </a:xfrm>
-          <a:prstGeom prst="oval">
-            <a:avLst/>
+          <p:cNvPr id="5" name="Text 3"/>
+          <p:cNvSpPr/>
+          <p:nvPr/>
+        </p:nvSpPr>
+        <p:spPr>
+          <a:xfrm>
+            <a:off x="548640" y="1371600"/>
+            <a:ext cx="914400" cy="274320"/>
+          </a:xfrm>
+          <a:prstGeom prst="rect">
+            <a:avLst/>
+          </a:prstGeom>
+          <a:noFill/>
+          <a:ln/>
+        </p:spPr>
+        <p:txBody>
+          <a:bodyPr wrap="square" rtlCol="0" anchor="ctr"/>
+          <a:lstStyle/>
+          <a:p>
+            <a:pPr indent="0" marL="0">
+              <a:buNone/>
+            </a:pPr>
+            <a:r>
+              <a:rPr lang="en-US" sz="1200" b="1" dirty="0">
+                <a:solidFill>
+                  <a:srgbClr val="5B6770"/>
+                </a:solidFill>
+                <a:latin typeface="Segoe UI" pitchFamily="34" charset="0"/>
+                <a:ea typeface="Segoe UI" pitchFamily="34" charset="-122"/>
+                <a:cs typeface="Segoe UI" pitchFamily="34" charset="-120"/>
+              </a:rPr>
+              <a:t>Legend:</a:t>
+            </a:r>
+            <a:endParaRPr lang="en-US" sz="1200" dirty="0"/>
+          </a:p>
+        </p:txBody>
+      </p:sp>
+      <p:sp>
+        <p:nvSpPr>
+          <p:cNvPr id="6" name="Shape 4"/>
+          <p:cNvSpPr/>
+          <p:nvPr/>
+        </p:nvSpPr>
+        <p:spPr>
+          <a:xfrm>
+            <a:off x="1463040" y="1399032"/>
+            <a:ext cx="274320" cy="219456"/>
+          </a:xfrm>
+          <a:prstGeom prst="roundRect">
+            <a:avLst>
+              <a:gd name="adj" fmla="val 12500"/>
+            </a:avLst>
+          </a:prstGeom>
+          <a:solidFill>
+            <a:srgbClr val="00695C"/>
+          </a:solidFill>
+          <a:ln/>
+        </p:spPr>
+      </p:sp>
+      <p:sp>
+        <p:nvSpPr>
+          <p:cNvPr id="7" name="Text 5"/>
+          <p:cNvSpPr/>
+          <p:nvPr/>
+        </p:nvSpPr>
+        <p:spPr>
+          <a:xfrm>
+            <a:off x="1810512" y="1371600"/>
+            <a:ext cx="2103120" cy="274320"/>
+          </a:xfrm>
+          <a:prstGeom prst="rect">
+            <a:avLst/>
+          </a:prstGeom>
+          <a:noFill/>
+          <a:ln/>
+        </p:spPr>
+        <p:txBody>
+          <a:bodyPr wrap="square" rtlCol="0" anchor="ctr"/>
+          <a:lstStyle/>
+          <a:p>
+            <a:pPr indent="0" marL="0">
+              <a:buNone/>
+            </a:pPr>
+            <a:r>
+              <a:rPr lang="en-US" sz="1200" b="1" dirty="0">
+                <a:solidFill>
+                  <a:srgbClr val="1B1B2F"/>
+                </a:solidFill>
+                <a:latin typeface="Segoe UI" pitchFamily="34" charset="0"/>
+                <a:ea typeface="Segoe UI" pitchFamily="34" charset="-122"/>
+                <a:cs typeface="Segoe UI" pitchFamily="34" charset="-120"/>
+              </a:rPr>
+              <a:t>AI Agent</a:t>
+            </a:r>
+            <a:endParaRPr lang="en-US" sz="1200" dirty="0"/>
+          </a:p>
+        </p:txBody>
+      </p:sp>
+      <p:sp>
+        <p:nvSpPr>
+          <p:cNvPr id="8" name="Shape 6"/>
+          <p:cNvSpPr/>
+          <p:nvPr/>
+        </p:nvSpPr>
+        <p:spPr>
+          <a:xfrm>
+            <a:off x="4114800" y="1399032"/>
+            <a:ext cx="274320" cy="219456"/>
+          </a:xfrm>
+          <a:prstGeom prst="roundRect">
+            <a:avLst>
+              <a:gd name="adj" fmla="val 12500"/>
+            </a:avLst>
           </a:prstGeom>
           <a:solidFill>
             <a:srgbClr val="0D47A1"/>
@@ -3344,14 +3509,14 @@
       </p:sp>
       <p:sp>
         <p:nvSpPr>
-          <p:cNvPr id="6" name="Text 4"/>
-          <p:cNvSpPr/>
-          <p:nvPr/>
-        </p:nvSpPr>
-        <p:spPr>
-          <a:xfrm>
-            <a:off x="548640" y="1600200"/>
-            <a:ext cx="640080" cy="640080"/>
+          <p:cNvPr id="9" name="Text 7"/>
+          <p:cNvSpPr/>
+          <p:nvPr/>
+        </p:nvSpPr>
+        <p:spPr>
+          <a:xfrm>
+            <a:off x="4462272" y="1371600"/>
+            <a:ext cx="2103120" cy="274320"/>
           </a:xfrm>
           <a:prstGeom prst="rect">
             <a:avLst/>
@@ -3363,11 +3528,158 @@
           <a:bodyPr wrap="square" rtlCol="0" anchor="ctr"/>
           <a:lstStyle/>
           <a:p>
+            <a:pPr indent="0" marL="0">
+              <a:buNone/>
+            </a:pPr>
+            <a:r>
+              <a:rPr lang="en-US" sz="1200" b="1" dirty="0">
+                <a:solidFill>
+                  <a:srgbClr val="1B1B2F"/>
+                </a:solidFill>
+                <a:latin typeface="Segoe UI" pitchFamily="34" charset="0"/>
+                <a:ea typeface="Segoe UI" pitchFamily="34" charset="-122"/>
+                <a:cs typeface="Segoe UI" pitchFamily="34" charset="-120"/>
+              </a:rPr>
+              <a:t>Automated</a:t>
+            </a:r>
+            <a:endParaRPr lang="en-US" sz="1200" dirty="0"/>
+          </a:p>
+        </p:txBody>
+      </p:sp>
+      <p:sp>
+        <p:nvSpPr>
+          <p:cNvPr id="10" name="Shape 8"/>
+          <p:cNvSpPr/>
+          <p:nvPr/>
+        </p:nvSpPr>
+        <p:spPr>
+          <a:xfrm>
+            <a:off x="6766560" y="1399032"/>
+            <a:ext cx="274320" cy="219456"/>
+          </a:xfrm>
+          <a:prstGeom prst="roundRect">
+            <a:avLst>
+              <a:gd name="adj" fmla="val 12500"/>
+            </a:avLst>
+          </a:prstGeom>
+          <a:solidFill>
+            <a:srgbClr val="E65100"/>
+          </a:solidFill>
+          <a:ln/>
+        </p:spPr>
+      </p:sp>
+      <p:sp>
+        <p:nvSpPr>
+          <p:cNvPr id="11" name="Text 9"/>
+          <p:cNvSpPr/>
+          <p:nvPr/>
+        </p:nvSpPr>
+        <p:spPr>
+          <a:xfrm>
+            <a:off x="7114032" y="1371600"/>
+            <a:ext cx="2103120" cy="274320"/>
+          </a:xfrm>
+          <a:prstGeom prst="rect">
+            <a:avLst/>
+          </a:prstGeom>
+          <a:noFill/>
+          <a:ln/>
+        </p:spPr>
+        <p:txBody>
+          <a:bodyPr wrap="square" rtlCol="0" anchor="ctr"/>
+          <a:lstStyle/>
+          <a:p>
+            <a:pPr indent="0" marL="0">
+              <a:buNone/>
+            </a:pPr>
+            <a:r>
+              <a:rPr lang="en-US" sz="1200" b="1" dirty="0">
+                <a:solidFill>
+                  <a:srgbClr val="1B1B2F"/>
+                </a:solidFill>
+                <a:latin typeface="Segoe UI" pitchFamily="34" charset="0"/>
+                <a:ea typeface="Segoe UI" pitchFamily="34" charset="-122"/>
+                <a:cs typeface="Segoe UI" pitchFamily="34" charset="-120"/>
+              </a:rPr>
+              <a:t>User Intervention</a:t>
+            </a:r>
+            <a:endParaRPr lang="en-US" sz="1200" dirty="0"/>
+          </a:p>
+        </p:txBody>
+      </p:sp>
+      <p:sp>
+        <p:nvSpPr>
+          <p:cNvPr id="12" name="Shape 10"/>
+          <p:cNvSpPr/>
+          <p:nvPr/>
+        </p:nvSpPr>
+        <p:spPr>
+          <a:xfrm>
+            <a:off x="457200" y="1965960"/>
+            <a:ext cx="2468880" cy="1417320"/>
+          </a:xfrm>
+          <a:prstGeom prst="roundRect">
+            <a:avLst>
+              <a:gd name="adj" fmla="val 5161"/>
+            </a:avLst>
+          </a:prstGeom>
+          <a:solidFill>
+            <a:srgbClr val="E1F0FF"/>
+          </a:solidFill>
+          <a:ln w="22225">
+            <a:solidFill>
+              <a:srgbClr val="0D47A1"/>
+            </a:solidFill>
+            <a:prstDash val="solid"/>
+          </a:ln>
+        </p:spPr>
+      </p:sp>
+      <p:sp>
+        <p:nvSpPr>
+          <p:cNvPr id="13" name="Shape 11"/>
+          <p:cNvSpPr/>
+          <p:nvPr/>
+        </p:nvSpPr>
+        <p:spPr>
+          <a:xfrm>
+            <a:off x="566928" y="2075688"/>
+            <a:ext cx="457200" cy="457200"/>
+          </a:xfrm>
+          <a:prstGeom prst="oval">
+            <a:avLst/>
+          </a:prstGeom>
+          <a:solidFill>
+            <a:srgbClr val="0D47A1"/>
+          </a:solidFill>
+          <a:ln/>
+        </p:spPr>
+      </p:sp>
+      <p:sp>
+        <p:nvSpPr>
+          <p:cNvPr id="14" name="Text 12"/>
+          <p:cNvSpPr/>
+          <p:nvPr/>
+        </p:nvSpPr>
+        <p:spPr>
+          <a:xfrm>
+            <a:off x="566928" y="2075688"/>
+            <a:ext cx="457200" cy="457200"/>
+          </a:xfrm>
+          <a:prstGeom prst="rect">
+            <a:avLst/>
+          </a:prstGeom>
+          <a:noFill/>
+          <a:ln/>
+        </p:spPr>
+        <p:txBody>
+          <a:bodyPr wrap="square" rtlCol="0" anchor="ctr"/>
+          <a:lstStyle/>
+          <a:p>
             <a:pPr algn="ctr" indent="0" marL="0">
               <a:buNone/>
             </a:pPr>
             <a:r>
-              <a:rPr lang="en-US" sz="2200" b="1" dirty="0">
+              <a:rPr lang="en-US" sz="1700" b="1" dirty="0">
                 <a:solidFill>
                   <a:srgbClr val="FFFFFF"/>
                 </a:solidFill>
@@ -3377,20 +3689,20 @@
               </a:rPr>
               <a:t>1</a:t>
             </a:r>
-            <a:endParaRPr lang="en-US" sz="2200" dirty="0"/>
+            <a:endParaRPr lang="en-US" sz="1700" dirty="0"/>
           </a:p>
         </p:txBody>
       </p:sp>
       <p:sp>
         <p:nvSpPr>
-          <p:cNvPr id="7" name="Text 5"/>
-          <p:cNvSpPr/>
-          <p:nvPr/>
-        </p:nvSpPr>
-        <p:spPr>
-          <a:xfrm>
-            <a:off x="1325880" y="1554480"/>
-            <a:ext cx="4663440" cy="411480"/>
+          <p:cNvPr id="15" name="Text 13"/>
+          <p:cNvSpPr/>
+          <p:nvPr/>
+        </p:nvSpPr>
+        <p:spPr>
+          <a:xfrm>
+            <a:off x="1097280" y="2057400"/>
+            <a:ext cx="1737360" cy="548640"/>
           </a:xfrm>
           <a:prstGeom prst="rect">
             <a:avLst/>
@@ -3406,46 +3718,63 @@
               <a:buNone/>
             </a:pPr>
             <a:r>
-              <a:rPr lang="en-US" sz="1600" b="1" dirty="0">
+              <a:rPr lang="en-US" sz="1350" b="1" dirty="0">
                 <a:solidFill>
-                  <a:srgbClr val="1A237E"/>
+                  <a:srgbClr val="1B1B2F"/>
                 </a:solidFill>
                 <a:latin typeface="Segoe UI" pitchFamily="34" charset="0"/>
                 <a:ea typeface="Segoe UI" pitchFamily="34" charset="-122"/>
                 <a:cs typeface="Segoe UI" pitchFamily="34" charset="-120"/>
               </a:rPr>
-              <a:t>Baseline Capture</a:t>
-            </a:r>
-            <a:endParaRPr lang="en-US" sz="1600" dirty="0"/>
-          </a:p>
-        </p:txBody>
-      </p:sp>
-      <p:sp>
-        <p:nvSpPr>
-          <p:cNvPr id="8" name="Text 6"/>
-          <p:cNvSpPr/>
-          <p:nvPr/>
-        </p:nvSpPr>
-        <p:spPr>
-          <a:xfrm>
-            <a:off x="1325880" y="1965960"/>
-            <a:ext cx="4663440" cy="822960"/>
-          </a:xfrm>
-          <a:prstGeom prst="rect">
-            <a:avLst/>
-          </a:prstGeom>
-          <a:noFill/>
-          <a:ln/>
-        </p:spPr>
-        <p:txBody>
-          <a:bodyPr wrap="square" rtlCol="0" anchor="ctr"/>
-          <a:lstStyle/>
+              <a:t>Baseline</a:t>
+            </a:r>
+            <a:endParaRPr lang="en-US" sz="1350" dirty="0"/>
+          </a:p>
           <a:p>
             <a:pPr indent="0" marL="0">
               <a:buNone/>
             </a:pPr>
             <a:r>
-              <a:rPr lang="en-US" sz="1250" dirty="0">
+              <a:rPr lang="en-US" sz="1350" b="1" dirty="0">
+                <a:solidFill>
+                  <a:srgbClr val="1B1B2F"/>
+                </a:solidFill>
+                <a:latin typeface="Segoe UI" pitchFamily="34" charset="0"/>
+                <a:ea typeface="Segoe UI" pitchFamily="34" charset="-122"/>
+                <a:cs typeface="Segoe UI" pitchFamily="34" charset="-120"/>
+              </a:rPr>
+              <a:t>Capture</a:t>
+            </a:r>
+            <a:endParaRPr lang="en-US" sz="1350" dirty="0"/>
+          </a:p>
+        </p:txBody>
+      </p:sp>
+      <p:sp>
+        <p:nvSpPr>
+          <p:cNvPr id="16" name="Text 14"/>
+          <p:cNvSpPr/>
+          <p:nvPr/>
+        </p:nvSpPr>
+        <p:spPr>
+          <a:xfrm>
+            <a:off x="594360" y="2624328"/>
+            <a:ext cx="2194560" cy="502920"/>
+          </a:xfrm>
+          <a:prstGeom prst="rect">
+            <a:avLst/>
+          </a:prstGeom>
+          <a:noFill/>
+          <a:ln/>
+        </p:spPr>
+        <p:txBody>
+          <a:bodyPr wrap="square" rtlCol="0" anchor="t"/>
+          <a:lstStyle/>
+          <a:p>
+            <a:pPr indent="0" marL="0">
+              <a:buNone/>
+            </a:pPr>
+            <a:r>
+              <a:rPr lang="en-US" sz="1050" dirty="0">
                 <a:solidFill>
                   <a:srgbClr val="5B6770"/>
                 </a:solidFill>
@@ -3453,25 +3782,27 @@
                 <a:ea typeface="Segoe UI" pitchFamily="34" charset="-122"/>
                 <a:cs typeface="Segoe UI" pitchFamily="34" charset="-120"/>
               </a:rPr>
-              <a:t>Records each deployment's known-good spec (image, resources, replicas, env, ports, command).</a:t>
-            </a:r>
-            <a:endParaRPr lang="en-US" sz="1250" dirty="0"/>
+              <a:t>System records known-good spec</a:t>
+            </a:r>
+            <a:endParaRPr lang="en-US" sz="1050" dirty="0"/>
           </a:p>
         </p:txBody>
       </p:sp>
       <p:sp>
         <p:nvSpPr>
-          <p:cNvPr id="9" name="Shape 7"/>
-          <p:cNvSpPr/>
-          <p:nvPr/>
-        </p:nvSpPr>
-        <p:spPr>
-          <a:xfrm>
-            <a:off x="6217920" y="1600200"/>
-            <a:ext cx="640080" cy="640080"/>
-          </a:xfrm>
-          <a:prstGeom prst="oval">
-            <a:avLst/>
+          <p:cNvPr id="17" name="Shape 15"/>
+          <p:cNvSpPr/>
+          <p:nvPr/>
+        </p:nvSpPr>
+        <p:spPr>
+          <a:xfrm>
+            <a:off x="1691640" y="3081528"/>
+            <a:ext cx="1143000" cy="237744"/>
+          </a:xfrm>
+          <a:prstGeom prst="roundRect">
+            <a:avLst>
+              <a:gd name="adj" fmla="val 11538"/>
+            </a:avLst>
           </a:prstGeom>
           <a:solidFill>
             <a:srgbClr val="0D47A1"/>
@@ -3481,14 +3812,14 @@
       </p:sp>
       <p:sp>
         <p:nvSpPr>
-          <p:cNvPr id="10" name="Text 8"/>
-          <p:cNvSpPr/>
-          <p:nvPr/>
-        </p:nvSpPr>
-        <p:spPr>
-          <a:xfrm>
-            <a:off x="6217920" y="1600200"/>
-            <a:ext cx="640080" cy="640080"/>
+          <p:cNvPr id="18" name="Text 16"/>
+          <p:cNvSpPr/>
+          <p:nvPr/>
+        </p:nvSpPr>
+        <p:spPr>
+          <a:xfrm>
+            <a:off x="1691640" y="3081528"/>
+            <a:ext cx="1143000" cy="237744"/>
           </a:xfrm>
           <a:prstGeom prst="rect">
             <a:avLst/>
@@ -3504,7 +3835,93 @@
               <a:buNone/>
             </a:pPr>
             <a:r>
-              <a:rPr lang="en-US" sz="2200" b="1" dirty="0">
+              <a:rPr lang="en-US" sz="850" b="1" dirty="0">
+                <a:solidFill>
+                  <a:srgbClr val="FFFFFF"/>
+                </a:solidFill>
+                <a:latin typeface="Segoe UI" pitchFamily="34" charset="0"/>
+                <a:ea typeface="Segoe UI" pitchFamily="34" charset="-122"/>
+                <a:cs typeface="Segoe UI" pitchFamily="34" charset="-120"/>
+              </a:rPr>
+              <a:t>Automated</a:t>
+            </a:r>
+            <a:endParaRPr lang="en-US" sz="850" dirty="0"/>
+          </a:p>
+        </p:txBody>
+      </p:sp>
+      <p:sp>
+        <p:nvSpPr>
+          <p:cNvPr id="19" name="Shape 17"/>
+          <p:cNvSpPr/>
+          <p:nvPr/>
+        </p:nvSpPr>
+        <p:spPr>
+          <a:xfrm>
+            <a:off x="3246120" y="1965960"/>
+            <a:ext cx="2468880" cy="1417320"/>
+          </a:xfrm>
+          <a:prstGeom prst="roundRect">
+            <a:avLst>
+              <a:gd name="adj" fmla="val 5161"/>
+            </a:avLst>
+          </a:prstGeom>
+          <a:solidFill>
+            <a:srgbClr val="E0F2F1"/>
+          </a:solidFill>
+          <a:ln w="22225">
+            <a:solidFill>
+              <a:srgbClr val="00695C"/>
+            </a:solidFill>
+            <a:prstDash val="solid"/>
+          </a:ln>
+        </p:spPr>
+      </p:sp>
+      <p:sp>
+        <p:nvSpPr>
+          <p:cNvPr id="20" name="Shape 18"/>
+          <p:cNvSpPr/>
+          <p:nvPr/>
+        </p:nvSpPr>
+        <p:spPr>
+          <a:xfrm>
+            <a:off x="3355848" y="2075688"/>
+            <a:ext cx="457200" cy="457200"/>
+          </a:xfrm>
+          <a:prstGeom prst="oval">
+            <a:avLst/>
+          </a:prstGeom>
+          <a:solidFill>
+            <a:srgbClr val="00695C"/>
+          </a:solidFill>
+          <a:ln/>
+        </p:spPr>
+      </p:sp>
+      <p:sp>
+        <p:nvSpPr>
+          <p:cNvPr id="21" name="Text 19"/>
+          <p:cNvSpPr/>
+          <p:nvPr/>
+        </p:nvSpPr>
+        <p:spPr>
+          <a:xfrm>
+            <a:off x="3355848" y="2075688"/>
+            <a:ext cx="457200" cy="457200"/>
+          </a:xfrm>
+          <a:prstGeom prst="rect">
+            <a:avLst/>
+          </a:prstGeom>
+          <a:noFill/>
+          <a:ln/>
+        </p:spPr>
+        <p:txBody>
+          <a:bodyPr wrap="square" rtlCol="0" anchor="ctr"/>
+          <a:lstStyle/>
+          <a:p>
+            <a:pPr algn="ctr" indent="0" marL="0">
+              <a:buNone/>
+            </a:pPr>
+            <a:r>
+              <a:rPr lang="en-US" sz="1700" b="1" dirty="0">
                 <a:solidFill>
                   <a:srgbClr val="FFFFFF"/>
                 </a:solidFill>
@@ -3514,20 +3931,20 @@
               </a:rPr>
               <a:t>2</a:t>
             </a:r>
-            <a:endParaRPr lang="en-US" sz="2200" dirty="0"/>
+            <a:endParaRPr lang="en-US" sz="1700" dirty="0"/>
           </a:p>
         </p:txBody>
       </p:sp>
       <p:sp>
         <p:nvSpPr>
-          <p:cNvPr id="11" name="Text 9"/>
-          <p:cNvSpPr/>
-          <p:nvPr/>
-        </p:nvSpPr>
-        <p:spPr>
-          <a:xfrm>
-            <a:off x="6995160" y="1554480"/>
-            <a:ext cx="4663440" cy="411480"/>
+          <p:cNvPr id="22" name="Text 20"/>
+          <p:cNvSpPr/>
+          <p:nvPr/>
+        </p:nvSpPr>
+        <p:spPr>
+          <a:xfrm>
+            <a:off x="3886200" y="2057400"/>
+            <a:ext cx="1737360" cy="548640"/>
           </a:xfrm>
           <a:prstGeom prst="rect">
             <a:avLst/>
@@ -3543,46 +3960,63 @@
               <a:buNone/>
             </a:pPr>
             <a:r>
-              <a:rPr lang="en-US" sz="1600" b="1" dirty="0">
+              <a:rPr lang="en-US" sz="1350" b="1" dirty="0">
                 <a:solidFill>
-                  <a:srgbClr val="1A237E"/>
+                  <a:srgbClr val="1B1B2F"/>
                 </a:solidFill>
                 <a:latin typeface="Segoe UI" pitchFamily="34" charset="0"/>
                 <a:ea typeface="Segoe UI" pitchFamily="34" charset="-122"/>
                 <a:cs typeface="Segoe UI" pitchFamily="34" charset="-120"/>
               </a:rPr>
-              <a:t>Continuous Watch</a:t>
-            </a:r>
-            <a:endParaRPr lang="en-US" sz="1600" dirty="0"/>
-          </a:p>
-        </p:txBody>
-      </p:sp>
-      <p:sp>
-        <p:nvSpPr>
-          <p:cNvPr id="12" name="Text 10"/>
-          <p:cNvSpPr/>
-          <p:nvPr/>
-        </p:nvSpPr>
-        <p:spPr>
-          <a:xfrm>
-            <a:off x="6995160" y="1965960"/>
-            <a:ext cx="4663440" cy="822960"/>
-          </a:xfrm>
-          <a:prstGeom prst="rect">
-            <a:avLst/>
-          </a:prstGeom>
-          <a:noFill/>
-          <a:ln/>
-        </p:spPr>
-        <p:txBody>
-          <a:bodyPr wrap="square" rtlCol="0" anchor="ctr"/>
-          <a:lstStyle/>
+              <a:t>Continuous</a:t>
+            </a:r>
+            <a:endParaRPr lang="en-US" sz="1350" dirty="0"/>
+          </a:p>
           <a:p>
             <a:pPr indent="0" marL="0">
               <a:buNone/>
             </a:pPr>
             <a:r>
-              <a:rPr lang="en-US" sz="1250" dirty="0">
+              <a:rPr lang="en-US" sz="1350" b="1" dirty="0">
+                <a:solidFill>
+                  <a:srgbClr val="1B1B2F"/>
+                </a:solidFill>
+                <a:latin typeface="Segoe UI" pitchFamily="34" charset="0"/>
+                <a:ea typeface="Segoe UI" pitchFamily="34" charset="-122"/>
+                <a:cs typeface="Segoe UI" pitchFamily="34" charset="-120"/>
+              </a:rPr>
+              <a:t>Watch</a:t>
+            </a:r>
+            <a:endParaRPr lang="en-US" sz="1350" dirty="0"/>
+          </a:p>
+        </p:txBody>
+      </p:sp>
+      <p:sp>
+        <p:nvSpPr>
+          <p:cNvPr id="23" name="Text 21"/>
+          <p:cNvSpPr/>
+          <p:nvPr/>
+        </p:nvSpPr>
+        <p:spPr>
+          <a:xfrm>
+            <a:off x="3383280" y="2624328"/>
+            <a:ext cx="2194560" cy="502920"/>
+          </a:xfrm>
+          <a:prstGeom prst="rect">
+            <a:avLst/>
+          </a:prstGeom>
+          <a:noFill/>
+          <a:ln/>
+        </p:spPr>
+        <p:txBody>
+          <a:bodyPr wrap="square" rtlCol="0" anchor="t"/>
+          <a:lstStyle/>
+          <a:p>
+            <a:pPr indent="0" marL="0">
+              <a:buNone/>
+            </a:pPr>
+            <a:r>
+              <a:rPr lang="en-US" sz="1050" dirty="0">
                 <a:solidFill>
                   <a:srgbClr val="5B6770"/>
                 </a:solidFill>
@@ -3590,42 +4024,44 @@
                 <a:ea typeface="Segoe UI" pitchFamily="34" charset="-122"/>
                 <a:cs typeface="Segoe UI" pitchFamily="34" charset="-120"/>
               </a:rPr>
-              <a:t>Re-scans all workloads every 1–5 min using generation / resourceVersion deltas.</a:t>
-            </a:r>
-            <a:endParaRPr lang="en-US" sz="1250" dirty="0"/>
+              <a:t>Re-scan every 1–5 min vs baseline</a:t>
+            </a:r>
+            <a:endParaRPr lang="en-US" sz="1050" dirty="0"/>
           </a:p>
         </p:txBody>
       </p:sp>
       <p:sp>
         <p:nvSpPr>
-          <p:cNvPr id="13" name="Shape 11"/>
-          <p:cNvSpPr/>
-          <p:nvPr/>
-        </p:nvSpPr>
-        <p:spPr>
-          <a:xfrm>
-            <a:off x="548640" y="3108960"/>
-            <a:ext cx="640080" cy="640080"/>
-          </a:xfrm>
-          <a:prstGeom prst="oval">
-            <a:avLst/>
+          <p:cNvPr id="24" name="Shape 22"/>
+          <p:cNvSpPr/>
+          <p:nvPr/>
+        </p:nvSpPr>
+        <p:spPr>
+          <a:xfrm>
+            <a:off x="4480560" y="3081528"/>
+            <a:ext cx="1143000" cy="237744"/>
+          </a:xfrm>
+          <a:prstGeom prst="roundRect">
+            <a:avLst>
+              <a:gd name="adj" fmla="val 11538"/>
+            </a:avLst>
           </a:prstGeom>
           <a:solidFill>
-            <a:srgbClr val="0D47A1"/>
+            <a:srgbClr val="00695C"/>
           </a:solidFill>
           <a:ln/>
         </p:spPr>
       </p:sp>
       <p:sp>
         <p:nvSpPr>
-          <p:cNvPr id="14" name="Text 12"/>
-          <p:cNvSpPr/>
-          <p:nvPr/>
-        </p:nvSpPr>
-        <p:spPr>
-          <a:xfrm>
-            <a:off x="548640" y="3108960"/>
-            <a:ext cx="640080" cy="640080"/>
+          <p:cNvPr id="25" name="Text 23"/>
+          <p:cNvSpPr/>
+          <p:nvPr/>
+        </p:nvSpPr>
+        <p:spPr>
+          <a:xfrm>
+            <a:off x="4480560" y="3081528"/>
+            <a:ext cx="1143000" cy="237744"/>
           </a:xfrm>
           <a:prstGeom prst="rect">
             <a:avLst/>
@@ -3641,7 +4077,93 @@
               <a:buNone/>
             </a:pPr>
             <a:r>
-              <a:rPr lang="en-US" sz="2200" b="1" dirty="0">
+              <a:rPr lang="en-US" sz="850" b="1" dirty="0">
+                <a:solidFill>
+                  <a:srgbClr val="FFFFFF"/>
+                </a:solidFill>
+                <a:latin typeface="Segoe UI" pitchFamily="34" charset="0"/>
+                <a:ea typeface="Segoe UI" pitchFamily="34" charset="-122"/>
+                <a:cs typeface="Segoe UI" pitchFamily="34" charset="-120"/>
+              </a:rPr>
+              <a:t>AI Agent</a:t>
+            </a:r>
+            <a:endParaRPr lang="en-US" sz="850" dirty="0"/>
+          </a:p>
+        </p:txBody>
+      </p:sp>
+      <p:sp>
+        <p:nvSpPr>
+          <p:cNvPr id="26" name="Shape 24"/>
+          <p:cNvSpPr/>
+          <p:nvPr/>
+        </p:nvSpPr>
+        <p:spPr>
+          <a:xfrm>
+            <a:off x="6035040" y="1965960"/>
+            <a:ext cx="2468880" cy="1417320"/>
+          </a:xfrm>
+          <a:prstGeom prst="roundRect">
+            <a:avLst>
+              <a:gd name="adj" fmla="val 5161"/>
+            </a:avLst>
+          </a:prstGeom>
+          <a:solidFill>
+            <a:srgbClr val="E0F2F1"/>
+          </a:solidFill>
+          <a:ln w="22225">
+            <a:solidFill>
+              <a:srgbClr val="00695C"/>
+            </a:solidFill>
+            <a:prstDash val="solid"/>
+          </a:ln>
+        </p:spPr>
+      </p:sp>
+      <p:sp>
+        <p:nvSpPr>
+          <p:cNvPr id="27" name="Shape 25"/>
+          <p:cNvSpPr/>
+          <p:nvPr/>
+        </p:nvSpPr>
+        <p:spPr>
+          <a:xfrm>
+            <a:off x="6144768" y="2075688"/>
+            <a:ext cx="457200" cy="457200"/>
+          </a:xfrm>
+          <a:prstGeom prst="oval">
+            <a:avLst/>
+          </a:prstGeom>
+          <a:solidFill>
+            <a:srgbClr val="00695C"/>
+          </a:solidFill>
+          <a:ln/>
+        </p:spPr>
+      </p:sp>
+      <p:sp>
+        <p:nvSpPr>
+          <p:cNvPr id="28" name="Text 26"/>
+          <p:cNvSpPr/>
+          <p:nvPr/>
+        </p:nvSpPr>
+        <p:spPr>
+          <a:xfrm>
+            <a:off x="6144768" y="2075688"/>
+            <a:ext cx="457200" cy="457200"/>
+          </a:xfrm>
+          <a:prstGeom prst="rect">
+            <a:avLst/>
+          </a:prstGeom>
+          <a:noFill/>
+          <a:ln/>
+        </p:spPr>
+        <p:txBody>
+          <a:bodyPr wrap="square" rtlCol="0" anchor="ctr"/>
+          <a:lstStyle/>
+          <a:p>
+            <a:pPr algn="ctr" indent="0" marL="0">
+              <a:buNone/>
+            </a:pPr>
+            <a:r>
+              <a:rPr lang="en-US" sz="1700" b="1" dirty="0">
                 <a:solidFill>
                   <a:srgbClr val="FFFFFF"/>
                 </a:solidFill>
@@ -3651,20 +4173,20 @@
               </a:rPr>
               <a:t>3</a:t>
             </a:r>
-            <a:endParaRPr lang="en-US" sz="2200" dirty="0"/>
+            <a:endParaRPr lang="en-US" sz="1700" dirty="0"/>
           </a:p>
         </p:txBody>
       </p:sp>
       <p:sp>
         <p:nvSpPr>
-          <p:cNvPr id="15" name="Text 13"/>
-          <p:cNvSpPr/>
-          <p:nvPr/>
-        </p:nvSpPr>
-        <p:spPr>
-          <a:xfrm>
-            <a:off x="1325880" y="3063240"/>
-            <a:ext cx="4663440" cy="411480"/>
+          <p:cNvPr id="29" name="Text 27"/>
+          <p:cNvSpPr/>
+          <p:nvPr/>
+        </p:nvSpPr>
+        <p:spPr>
+          <a:xfrm>
+            <a:off x="6675120" y="2057400"/>
+            <a:ext cx="1737360" cy="548640"/>
           </a:xfrm>
           <a:prstGeom prst="rect">
             <a:avLst/>
@@ -3680,46 +4202,63 @@
               <a:buNone/>
             </a:pPr>
             <a:r>
-              <a:rPr lang="en-US" sz="1600" b="1" dirty="0">
+              <a:rPr lang="en-US" sz="1350" b="1" dirty="0">
                 <a:solidFill>
-                  <a:srgbClr val="1A237E"/>
+                  <a:srgbClr val="1B1B2F"/>
                 </a:solidFill>
                 <a:latin typeface="Segoe UI" pitchFamily="34" charset="0"/>
                 <a:ea typeface="Segoe UI" pitchFamily="34" charset="-122"/>
                 <a:cs typeface="Segoe UI" pitchFamily="34" charset="-120"/>
               </a:rPr>
-              <a:t>Drift Detection</a:t>
-            </a:r>
-            <a:endParaRPr lang="en-US" sz="1600" dirty="0"/>
-          </a:p>
-        </p:txBody>
-      </p:sp>
-      <p:sp>
-        <p:nvSpPr>
-          <p:cNvPr id="16" name="Text 14"/>
-          <p:cNvSpPr/>
-          <p:nvPr/>
-        </p:nvSpPr>
-        <p:spPr>
-          <a:xfrm>
-            <a:off x="1325880" y="3474720"/>
-            <a:ext cx="4663440" cy="822960"/>
-          </a:xfrm>
-          <a:prstGeom prst="rect">
-            <a:avLst/>
-          </a:prstGeom>
-          <a:noFill/>
-          <a:ln/>
-        </p:spPr>
-        <p:txBody>
-          <a:bodyPr wrap="square" rtlCol="0" anchor="ctr"/>
-          <a:lstStyle/>
+              <a:t>Drift</a:t>
+            </a:r>
+            <a:endParaRPr lang="en-US" sz="1350" dirty="0"/>
+          </a:p>
           <a:p>
             <a:pPr indent="0" marL="0">
               <a:buNone/>
             </a:pPr>
             <a:r>
-              <a:rPr lang="en-US" sz="1250" dirty="0">
+              <a:rPr lang="en-US" sz="1350" b="1" dirty="0">
+                <a:solidFill>
+                  <a:srgbClr val="1B1B2F"/>
+                </a:solidFill>
+                <a:latin typeface="Segoe UI" pitchFamily="34" charset="0"/>
+                <a:ea typeface="Segoe UI" pitchFamily="34" charset="-122"/>
+                <a:cs typeface="Segoe UI" pitchFamily="34" charset="-120"/>
+              </a:rPr>
+              <a:t>Detected</a:t>
+            </a:r>
+            <a:endParaRPr lang="en-US" sz="1350" dirty="0"/>
+          </a:p>
+        </p:txBody>
+      </p:sp>
+      <p:sp>
+        <p:nvSpPr>
+          <p:cNvPr id="30" name="Text 28"/>
+          <p:cNvSpPr/>
+          <p:nvPr/>
+        </p:nvSpPr>
+        <p:spPr>
+          <a:xfrm>
+            <a:off x="6172200" y="2624328"/>
+            <a:ext cx="2194560" cy="502920"/>
+          </a:xfrm>
+          <a:prstGeom prst="rect">
+            <a:avLst/>
+          </a:prstGeom>
+          <a:noFill/>
+          <a:ln/>
+        </p:spPr>
+        <p:txBody>
+          <a:bodyPr wrap="square" rtlCol="0" anchor="t"/>
+          <a:lstStyle/>
+          <a:p>
+            <a:pPr indent="0" marL="0">
+              <a:buNone/>
+            </a:pPr>
+            <a:r>
+              <a:rPr lang="en-US" sz="1050" dirty="0">
                 <a:solidFill>
                   <a:srgbClr val="5B6770"/>
                 </a:solidFill>
@@ -3727,42 +4266,44 @@
                 <a:ea typeface="Segoe UI" pitchFamily="34" charset="-122"/>
                 <a:cs typeface="Segoe UI" pitchFamily="34" charset="-120"/>
               </a:rPr>
-              <a:t>Flags any out-of-GitOps change instantly, classified by severity.</a:t>
-            </a:r>
-            <a:endParaRPr lang="en-US" sz="1250" dirty="0"/>
+              <a:t>Out-of-GitOps change flagged + rated</a:t>
+            </a:r>
+            <a:endParaRPr lang="en-US" sz="1050" dirty="0"/>
           </a:p>
         </p:txBody>
       </p:sp>
       <p:sp>
         <p:nvSpPr>
-          <p:cNvPr id="17" name="Shape 15"/>
-          <p:cNvSpPr/>
-          <p:nvPr/>
-        </p:nvSpPr>
-        <p:spPr>
-          <a:xfrm>
-            <a:off x="6217920" y="3108960"/>
-            <a:ext cx="640080" cy="640080"/>
-          </a:xfrm>
-          <a:prstGeom prst="oval">
-            <a:avLst/>
+          <p:cNvPr id="31" name="Shape 29"/>
+          <p:cNvSpPr/>
+          <p:nvPr/>
+        </p:nvSpPr>
+        <p:spPr>
+          <a:xfrm>
+            <a:off x="7269480" y="3081528"/>
+            <a:ext cx="1143000" cy="237744"/>
+          </a:xfrm>
+          <a:prstGeom prst="roundRect">
+            <a:avLst>
+              <a:gd name="adj" fmla="val 11538"/>
+            </a:avLst>
           </a:prstGeom>
           <a:solidFill>
-            <a:srgbClr val="0D47A1"/>
+            <a:srgbClr val="00695C"/>
           </a:solidFill>
           <a:ln/>
         </p:spPr>
       </p:sp>
       <p:sp>
         <p:nvSpPr>
-          <p:cNvPr id="18" name="Text 16"/>
-          <p:cNvSpPr/>
-          <p:nvPr/>
-        </p:nvSpPr>
-        <p:spPr>
-          <a:xfrm>
-            <a:off x="6217920" y="3108960"/>
-            <a:ext cx="640080" cy="640080"/>
+          <p:cNvPr id="32" name="Text 30"/>
+          <p:cNvSpPr/>
+          <p:nvPr/>
+        </p:nvSpPr>
+        <p:spPr>
+          <a:xfrm>
+            <a:off x="7269480" y="3081528"/>
+            <a:ext cx="1143000" cy="237744"/>
           </a:xfrm>
           <a:prstGeom prst="rect">
             <a:avLst/>
@@ -3778,7 +4319,93 @@
               <a:buNone/>
             </a:pPr>
             <a:r>
-              <a:rPr lang="en-US" sz="2200" b="1" dirty="0">
+              <a:rPr lang="en-US" sz="850" b="1" dirty="0">
+                <a:solidFill>
+                  <a:srgbClr val="FFFFFF"/>
+                </a:solidFill>
+                <a:latin typeface="Segoe UI" pitchFamily="34" charset="0"/>
+                <a:ea typeface="Segoe UI" pitchFamily="34" charset="-122"/>
+                <a:cs typeface="Segoe UI" pitchFamily="34" charset="-120"/>
+              </a:rPr>
+              <a:t>AI Agent</a:t>
+            </a:r>
+            <a:endParaRPr lang="en-US" sz="850" dirty="0"/>
+          </a:p>
+        </p:txBody>
+      </p:sp>
+      <p:sp>
+        <p:nvSpPr>
+          <p:cNvPr id="33" name="Shape 31"/>
+          <p:cNvSpPr/>
+          <p:nvPr/>
+        </p:nvSpPr>
+        <p:spPr>
+          <a:xfrm>
+            <a:off x="8823960" y="1965960"/>
+            <a:ext cx="2468880" cy="1417320"/>
+          </a:xfrm>
+          <a:prstGeom prst="roundRect">
+            <a:avLst>
+              <a:gd name="adj" fmla="val 5161"/>
+            </a:avLst>
+          </a:prstGeom>
+          <a:solidFill>
+            <a:srgbClr val="E0F2F1"/>
+          </a:solidFill>
+          <a:ln w="22225">
+            <a:solidFill>
+              <a:srgbClr val="00695C"/>
+            </a:solidFill>
+            <a:prstDash val="solid"/>
+          </a:ln>
+        </p:spPr>
+      </p:sp>
+      <p:sp>
+        <p:nvSpPr>
+          <p:cNvPr id="34" name="Shape 32"/>
+          <p:cNvSpPr/>
+          <p:nvPr/>
+        </p:nvSpPr>
+        <p:spPr>
+          <a:xfrm>
+            <a:off x="8933688" y="2075688"/>
+            <a:ext cx="457200" cy="457200"/>
+          </a:xfrm>
+          <a:prstGeom prst="oval">
+            <a:avLst/>
+          </a:prstGeom>
+          <a:solidFill>
+            <a:srgbClr val="00695C"/>
+          </a:solidFill>
+          <a:ln/>
+        </p:spPr>
+      </p:sp>
+      <p:sp>
+        <p:nvSpPr>
+          <p:cNvPr id="35" name="Text 33"/>
+          <p:cNvSpPr/>
+          <p:nvPr/>
+        </p:nvSpPr>
+        <p:spPr>
+          <a:xfrm>
+            <a:off x="8933688" y="2075688"/>
+            <a:ext cx="457200" cy="457200"/>
+          </a:xfrm>
+          <a:prstGeom prst="rect">
+            <a:avLst/>
+          </a:prstGeom>
+          <a:noFill/>
+          <a:ln/>
+        </p:spPr>
+        <p:txBody>
+          <a:bodyPr wrap="square" rtlCol="0" anchor="ctr"/>
+          <a:lstStyle/>
+          <a:p>
+            <a:pPr algn="ctr" indent="0" marL="0">
+              <a:buNone/>
+            </a:pPr>
+            <a:r>
+              <a:rPr lang="en-US" sz="1700" b="1" dirty="0">
                 <a:solidFill>
                   <a:srgbClr val="FFFFFF"/>
                 </a:solidFill>
@@ -3788,20 +4415,20 @@
               </a:rPr>
               <a:t>4</a:t>
             </a:r>
-            <a:endParaRPr lang="en-US" sz="2200" dirty="0"/>
+            <a:endParaRPr lang="en-US" sz="1700" dirty="0"/>
           </a:p>
         </p:txBody>
       </p:sp>
       <p:sp>
         <p:nvSpPr>
-          <p:cNvPr id="19" name="Text 17"/>
-          <p:cNvSpPr/>
-          <p:nvPr/>
-        </p:nvSpPr>
-        <p:spPr>
-          <a:xfrm>
-            <a:off x="6995160" y="3063240"/>
-            <a:ext cx="4663440" cy="411480"/>
+          <p:cNvPr id="36" name="Text 34"/>
+          <p:cNvSpPr/>
+          <p:nvPr/>
+        </p:nvSpPr>
+        <p:spPr>
+          <a:xfrm>
+            <a:off x="9464040" y="2057400"/>
+            <a:ext cx="1737360" cy="548640"/>
           </a:xfrm>
           <a:prstGeom prst="rect">
             <a:avLst/>
@@ -3817,46 +4444,63 @@
               <a:buNone/>
             </a:pPr>
             <a:r>
-              <a:rPr lang="en-US" sz="1600" b="1" dirty="0">
+              <a:rPr lang="en-US" sz="1350" b="1" dirty="0">
                 <a:solidFill>
-                  <a:srgbClr val="1A237E"/>
+                  <a:srgbClr val="1B1B2F"/>
                 </a:solidFill>
                 <a:latin typeface="Segoe UI" pitchFamily="34" charset="0"/>
                 <a:ea typeface="Segoe UI" pitchFamily="34" charset="-122"/>
                 <a:cs typeface="Segoe UI" pitchFamily="34" charset="-120"/>
               </a:rPr>
-              <a:t>Natural-Language Diff</a:t>
-            </a:r>
-            <a:endParaRPr lang="en-US" sz="1600" dirty="0"/>
-          </a:p>
-        </p:txBody>
-      </p:sp>
-      <p:sp>
-        <p:nvSpPr>
-          <p:cNvPr id="20" name="Text 18"/>
-          <p:cNvSpPr/>
-          <p:nvPr/>
-        </p:nvSpPr>
-        <p:spPr>
-          <a:xfrm>
-            <a:off x="6995160" y="3474720"/>
-            <a:ext cx="4663440" cy="822960"/>
-          </a:xfrm>
-          <a:prstGeom prst="rect">
-            <a:avLst/>
-          </a:prstGeom>
-          <a:noFill/>
-          <a:ln/>
-        </p:spPr>
-        <p:txBody>
-          <a:bodyPr wrap="square" rtlCol="0" anchor="ctr"/>
-          <a:lstStyle/>
+              <a:t>Explain</a:t>
+            </a:r>
+            <a:endParaRPr lang="en-US" sz="1350" dirty="0"/>
+          </a:p>
           <a:p>
             <a:pPr indent="0" marL="0">
               <a:buNone/>
             </a:pPr>
             <a:r>
-              <a:rPr lang="en-US" sz="1250" dirty="0">
+              <a:rPr lang="en-US" sz="1350" b="1" dirty="0">
+                <a:solidFill>
+                  <a:srgbClr val="1B1B2F"/>
+                </a:solidFill>
+                <a:latin typeface="Segoe UI" pitchFamily="34" charset="0"/>
+                <a:ea typeface="Segoe UI" pitchFamily="34" charset="-122"/>
+                <a:cs typeface="Segoe UI" pitchFamily="34" charset="-120"/>
+              </a:rPr>
+              <a:t>Change</a:t>
+            </a:r>
+            <a:endParaRPr lang="en-US" sz="1350" dirty="0"/>
+          </a:p>
+        </p:txBody>
+      </p:sp>
+      <p:sp>
+        <p:nvSpPr>
+          <p:cNvPr id="37" name="Text 35"/>
+          <p:cNvSpPr/>
+          <p:nvPr/>
+        </p:nvSpPr>
+        <p:spPr>
+          <a:xfrm>
+            <a:off x="8961120" y="2624328"/>
+            <a:ext cx="2194560" cy="502920"/>
+          </a:xfrm>
+          <a:prstGeom prst="rect">
+            <a:avLst/>
+          </a:prstGeom>
+          <a:noFill/>
+          <a:ln/>
+        </p:spPr>
+        <p:txBody>
+          <a:bodyPr wrap="square" rtlCol="0" anchor="t"/>
+          <a:lstStyle/>
+          <a:p>
+            <a:pPr indent="0" marL="0">
+              <a:buNone/>
+            </a:pPr>
+            <a:r>
+              <a:rPr lang="en-US" sz="1050" dirty="0">
                 <a:solidFill>
                   <a:srgbClr val="5B6770"/>
                 </a:solidFill>
@@ -3864,42 +4508,44 @@
                 <a:ea typeface="Segoe UI" pitchFamily="34" charset="-122"/>
                 <a:cs typeface="Segoe UI" pitchFamily="34" charset="-120"/>
               </a:rPr>
-              <a:t>AI shows old vs new value, the field changed, and exactly when.</a:t>
-            </a:r>
-            <a:endParaRPr lang="en-US" sz="1250" dirty="0"/>
+              <a:t>AI: old vs new value, field &amp; time</a:t>
+            </a:r>
+            <a:endParaRPr lang="en-US" sz="1050" dirty="0"/>
           </a:p>
         </p:txBody>
       </p:sp>
       <p:sp>
         <p:nvSpPr>
-          <p:cNvPr id="21" name="Shape 19"/>
-          <p:cNvSpPr/>
-          <p:nvPr/>
-        </p:nvSpPr>
-        <p:spPr>
-          <a:xfrm>
-            <a:off x="548640" y="4617720"/>
-            <a:ext cx="640080" cy="640080"/>
-          </a:xfrm>
-          <a:prstGeom prst="oval">
-            <a:avLst/>
+          <p:cNvPr id="38" name="Shape 36"/>
+          <p:cNvSpPr/>
+          <p:nvPr/>
+        </p:nvSpPr>
+        <p:spPr>
+          <a:xfrm>
+            <a:off x="10058400" y="3081528"/>
+            <a:ext cx="1143000" cy="237744"/>
+          </a:xfrm>
+          <a:prstGeom prst="roundRect">
+            <a:avLst>
+              <a:gd name="adj" fmla="val 11538"/>
+            </a:avLst>
           </a:prstGeom>
           <a:solidFill>
-            <a:srgbClr val="0D47A1"/>
+            <a:srgbClr val="00695C"/>
           </a:solidFill>
           <a:ln/>
         </p:spPr>
       </p:sp>
       <p:sp>
         <p:nvSpPr>
-          <p:cNvPr id="22" name="Text 20"/>
-          <p:cNvSpPr/>
-          <p:nvPr/>
-        </p:nvSpPr>
-        <p:spPr>
-          <a:xfrm>
-            <a:off x="548640" y="4617720"/>
-            <a:ext cx="640080" cy="640080"/>
+          <p:cNvPr id="39" name="Text 37"/>
+          <p:cNvSpPr/>
+          <p:nvPr/>
+        </p:nvSpPr>
+        <p:spPr>
+          <a:xfrm>
+            <a:off x="10058400" y="3081528"/>
+            <a:ext cx="1143000" cy="237744"/>
           </a:xfrm>
           <a:prstGeom prst="rect">
             <a:avLst/>
@@ -3915,7 +4561,93 @@
               <a:buNone/>
             </a:pPr>
             <a:r>
-              <a:rPr lang="en-US" sz="2200" b="1" dirty="0">
+              <a:rPr lang="en-US" sz="850" b="1" dirty="0">
+                <a:solidFill>
+                  <a:srgbClr val="FFFFFF"/>
+                </a:solidFill>
+                <a:latin typeface="Segoe UI" pitchFamily="34" charset="0"/>
+                <a:ea typeface="Segoe UI" pitchFamily="34" charset="-122"/>
+                <a:cs typeface="Segoe UI" pitchFamily="34" charset="-120"/>
+              </a:rPr>
+              <a:t>AI Agent</a:t>
+            </a:r>
+            <a:endParaRPr lang="en-US" sz="850" dirty="0"/>
+          </a:p>
+        </p:txBody>
+      </p:sp>
+      <p:sp>
+        <p:nvSpPr>
+          <p:cNvPr id="40" name="Shape 38"/>
+          <p:cNvSpPr/>
+          <p:nvPr/>
+        </p:nvSpPr>
+        <p:spPr>
+          <a:xfrm>
+            <a:off x="8823960" y="4160520"/>
+            <a:ext cx="2468880" cy="1417320"/>
+          </a:xfrm>
+          <a:prstGeom prst="roundRect">
+            <a:avLst>
+              <a:gd name="adj" fmla="val 5161"/>
+            </a:avLst>
+          </a:prstGeom>
+          <a:solidFill>
+            <a:srgbClr val="FFF3E0"/>
+          </a:solidFill>
+          <a:ln w="22225">
+            <a:solidFill>
+              <a:srgbClr val="E65100"/>
+            </a:solidFill>
+            <a:prstDash val="solid"/>
+          </a:ln>
+        </p:spPr>
+      </p:sp>
+      <p:sp>
+        <p:nvSpPr>
+          <p:cNvPr id="41" name="Shape 39"/>
+          <p:cNvSpPr/>
+          <p:nvPr/>
+        </p:nvSpPr>
+        <p:spPr>
+          <a:xfrm>
+            <a:off x="8933688" y="4270248"/>
+            <a:ext cx="457200" cy="457200"/>
+          </a:xfrm>
+          <a:prstGeom prst="oval">
+            <a:avLst/>
+          </a:prstGeom>
+          <a:solidFill>
+            <a:srgbClr val="E65100"/>
+          </a:solidFill>
+          <a:ln/>
+        </p:spPr>
+      </p:sp>
+      <p:sp>
+        <p:nvSpPr>
+          <p:cNvPr id="42" name="Text 40"/>
+          <p:cNvSpPr/>
+          <p:nvPr/>
+        </p:nvSpPr>
+        <p:spPr>
+          <a:xfrm>
+            <a:off x="8933688" y="4270248"/>
+            <a:ext cx="457200" cy="457200"/>
+          </a:xfrm>
+          <a:prstGeom prst="rect">
+            <a:avLst/>
+          </a:prstGeom>
+          <a:noFill/>
+          <a:ln/>
+        </p:spPr>
+        <p:txBody>
+          <a:bodyPr wrap="square" rtlCol="0" anchor="ctr"/>
+          <a:lstStyle/>
+          <a:p>
+            <a:pPr algn="ctr" indent="0" marL="0">
+              <a:buNone/>
+            </a:pPr>
+            <a:r>
+              <a:rPr lang="en-US" sz="1700" b="1" dirty="0">
                 <a:solidFill>
                   <a:srgbClr val="FFFFFF"/>
                 </a:solidFill>
@@ -3925,20 +4657,20 @@
               </a:rPr>
               <a:t>5</a:t>
             </a:r>
-            <a:endParaRPr lang="en-US" sz="2200" dirty="0"/>
+            <a:endParaRPr lang="en-US" sz="1700" dirty="0"/>
           </a:p>
         </p:txBody>
       </p:sp>
       <p:sp>
         <p:nvSpPr>
-          <p:cNvPr id="23" name="Text 21"/>
-          <p:cNvSpPr/>
-          <p:nvPr/>
-        </p:nvSpPr>
-        <p:spPr>
-          <a:xfrm>
-            <a:off x="1325880" y="4572000"/>
-            <a:ext cx="4663440" cy="411480"/>
+          <p:cNvPr id="43" name="Text 41"/>
+          <p:cNvSpPr/>
+          <p:nvPr/>
+        </p:nvSpPr>
+        <p:spPr>
+          <a:xfrm>
+            <a:off x="9464040" y="4251960"/>
+            <a:ext cx="1737360" cy="548640"/>
           </a:xfrm>
           <a:prstGeom prst="rect">
             <a:avLst/>
@@ -3954,46 +4686,63 @@
               <a:buNone/>
             </a:pPr>
             <a:r>
-              <a:rPr lang="en-US" sz="1600" b="1" dirty="0">
+              <a:rPr lang="en-US" sz="1350" b="1" dirty="0">
                 <a:solidFill>
-                  <a:srgbClr val="1A237E"/>
+                  <a:srgbClr val="1B1B2F"/>
                 </a:solidFill>
                 <a:latin typeface="Segoe UI" pitchFamily="34" charset="0"/>
                 <a:ea typeface="Segoe UI" pitchFamily="34" charset="-122"/>
                 <a:cs typeface="Segoe UI" pitchFamily="34" charset="-120"/>
               </a:rPr>
-              <a:t>One-Click Rollback</a:t>
-            </a:r>
-            <a:endParaRPr lang="en-US" sz="1600" dirty="0"/>
-          </a:p>
-        </p:txBody>
-      </p:sp>
-      <p:sp>
-        <p:nvSpPr>
-          <p:cNvPr id="24" name="Text 22"/>
-          <p:cNvSpPr/>
-          <p:nvPr/>
-        </p:nvSpPr>
-        <p:spPr>
-          <a:xfrm>
-            <a:off x="1325880" y="4983480"/>
-            <a:ext cx="4663440" cy="822960"/>
-          </a:xfrm>
-          <a:prstGeom prst="rect">
-            <a:avLst/>
-          </a:prstGeom>
-          <a:noFill/>
-          <a:ln/>
-        </p:spPr>
-        <p:txBody>
-          <a:bodyPr wrap="square" rtlCol="0" anchor="ctr"/>
-          <a:lstStyle/>
+              <a:t>Review &amp;</a:t>
+            </a:r>
+            <a:endParaRPr lang="en-US" sz="1350" dirty="0"/>
+          </a:p>
           <a:p>
             <a:pPr indent="0" marL="0">
               <a:buNone/>
             </a:pPr>
             <a:r>
-              <a:rPr lang="en-US" sz="1250" dirty="0">
+              <a:rPr lang="en-US" sz="1350" b="1" dirty="0">
+                <a:solidFill>
+                  <a:srgbClr val="1B1B2F"/>
+                </a:solidFill>
+                <a:latin typeface="Segoe UI" pitchFamily="34" charset="0"/>
+                <a:ea typeface="Segoe UI" pitchFamily="34" charset="-122"/>
+                <a:cs typeface="Segoe UI" pitchFamily="34" charset="-120"/>
+              </a:rPr>
+              <a:t>Decide</a:t>
+            </a:r>
+            <a:endParaRPr lang="en-US" sz="1350" dirty="0"/>
+          </a:p>
+        </p:txBody>
+      </p:sp>
+      <p:sp>
+        <p:nvSpPr>
+          <p:cNvPr id="44" name="Text 42"/>
+          <p:cNvSpPr/>
+          <p:nvPr/>
+        </p:nvSpPr>
+        <p:spPr>
+          <a:xfrm>
+            <a:off x="8961120" y="4818888"/>
+            <a:ext cx="2194560" cy="502920"/>
+          </a:xfrm>
+          <a:prstGeom prst="rect">
+            <a:avLst/>
+          </a:prstGeom>
+          <a:noFill/>
+          <a:ln/>
+        </p:spPr>
+        <p:txBody>
+          <a:bodyPr wrap="square" rtlCol="0" anchor="t"/>
+          <a:lstStyle/>
+          <a:p>
+            <a:pPr indent="0" marL="0">
+              <a:buNone/>
+            </a:pPr>
+            <a:r>
+              <a:rPr lang="en-US" sz="1050" dirty="0">
                 <a:solidFill>
                   <a:srgbClr val="5B6770"/>
                 </a:solidFill>
@@ -4001,42 +4750,44 @@
                 <a:ea typeface="Segoe UI" pitchFamily="34" charset="-122"/>
                 <a:cs typeface="Segoe UI" pitchFamily="34" charset="-120"/>
               </a:rPr>
-              <a:t>Strategic-merge patch restores the full container spec + rolling restart.</a:t>
-            </a:r>
-            <a:endParaRPr lang="en-US" sz="1250" dirty="0"/>
+              <a:t>Operator sees the change &amp; options</a:t>
+            </a:r>
+            <a:endParaRPr lang="en-US" sz="1050" dirty="0"/>
           </a:p>
         </p:txBody>
       </p:sp>
       <p:sp>
         <p:nvSpPr>
-          <p:cNvPr id="25" name="Shape 23"/>
-          <p:cNvSpPr/>
-          <p:nvPr/>
-        </p:nvSpPr>
-        <p:spPr>
-          <a:xfrm>
-            <a:off x="6217920" y="4617720"/>
-            <a:ext cx="640080" cy="640080"/>
-          </a:xfrm>
-          <a:prstGeom prst="oval">
-            <a:avLst/>
+          <p:cNvPr id="45" name="Shape 43"/>
+          <p:cNvSpPr/>
+          <p:nvPr/>
+        </p:nvSpPr>
+        <p:spPr>
+          <a:xfrm>
+            <a:off x="10058400" y="5276088"/>
+            <a:ext cx="1143000" cy="237744"/>
+          </a:xfrm>
+          <a:prstGeom prst="roundRect">
+            <a:avLst>
+              <a:gd name="adj" fmla="val 11538"/>
+            </a:avLst>
           </a:prstGeom>
           <a:solidFill>
-            <a:srgbClr val="0D47A1"/>
+            <a:srgbClr val="E65100"/>
           </a:solidFill>
           <a:ln/>
         </p:spPr>
       </p:sp>
       <p:sp>
         <p:nvSpPr>
-          <p:cNvPr id="26" name="Text 24"/>
-          <p:cNvSpPr/>
-          <p:nvPr/>
-        </p:nvSpPr>
-        <p:spPr>
-          <a:xfrm>
-            <a:off x="6217920" y="4617720"/>
-            <a:ext cx="640080" cy="640080"/>
+          <p:cNvPr id="46" name="Text 44"/>
+          <p:cNvSpPr/>
+          <p:nvPr/>
+        </p:nvSpPr>
+        <p:spPr>
+          <a:xfrm>
+            <a:off x="10058400" y="5276088"/>
+            <a:ext cx="1143000" cy="237744"/>
           </a:xfrm>
           <a:prstGeom prst="rect">
             <a:avLst/>
@@ -4052,7 +4803,93 @@
               <a:buNone/>
             </a:pPr>
             <a:r>
-              <a:rPr lang="en-US" sz="2200" b="1" dirty="0">
+              <a:rPr lang="en-US" sz="850" b="1" dirty="0">
+                <a:solidFill>
+                  <a:srgbClr val="FFFFFF"/>
+                </a:solidFill>
+                <a:latin typeface="Segoe UI" pitchFamily="34" charset="0"/>
+                <a:ea typeface="Segoe UI" pitchFamily="34" charset="-122"/>
+                <a:cs typeface="Segoe UI" pitchFamily="34" charset="-120"/>
+              </a:rPr>
+              <a:t>User Intervention</a:t>
+            </a:r>
+            <a:endParaRPr lang="en-US" sz="850" dirty="0"/>
+          </a:p>
+        </p:txBody>
+      </p:sp>
+      <p:sp>
+        <p:nvSpPr>
+          <p:cNvPr id="47" name="Shape 45"/>
+          <p:cNvSpPr/>
+          <p:nvPr/>
+        </p:nvSpPr>
+        <p:spPr>
+          <a:xfrm>
+            <a:off x="6035040" y="4160520"/>
+            <a:ext cx="2468880" cy="1417320"/>
+          </a:xfrm>
+          <a:prstGeom prst="roundRect">
+            <a:avLst>
+              <a:gd name="adj" fmla="val 5161"/>
+            </a:avLst>
+          </a:prstGeom>
+          <a:solidFill>
+            <a:srgbClr val="FFF3E0"/>
+          </a:solidFill>
+          <a:ln w="22225">
+            <a:solidFill>
+              <a:srgbClr val="E65100"/>
+            </a:solidFill>
+            <a:prstDash val="solid"/>
+          </a:ln>
+        </p:spPr>
+      </p:sp>
+      <p:sp>
+        <p:nvSpPr>
+          <p:cNvPr id="48" name="Shape 46"/>
+          <p:cNvSpPr/>
+          <p:nvPr/>
+        </p:nvSpPr>
+        <p:spPr>
+          <a:xfrm>
+            <a:off x="6144768" y="4270248"/>
+            <a:ext cx="457200" cy="457200"/>
+          </a:xfrm>
+          <a:prstGeom prst="oval">
+            <a:avLst/>
+          </a:prstGeom>
+          <a:solidFill>
+            <a:srgbClr val="E65100"/>
+          </a:solidFill>
+          <a:ln/>
+        </p:spPr>
+      </p:sp>
+      <p:sp>
+        <p:nvSpPr>
+          <p:cNvPr id="49" name="Text 47"/>
+          <p:cNvSpPr/>
+          <p:nvPr/>
+        </p:nvSpPr>
+        <p:spPr>
+          <a:xfrm>
+            <a:off x="6144768" y="4270248"/>
+            <a:ext cx="457200" cy="457200"/>
+          </a:xfrm>
+          <a:prstGeom prst="rect">
+            <a:avLst/>
+          </a:prstGeom>
+          <a:noFill/>
+          <a:ln/>
+        </p:spPr>
+        <p:txBody>
+          <a:bodyPr wrap="square" rtlCol="0" anchor="ctr"/>
+          <a:lstStyle/>
+          <a:p>
+            <a:pPr algn="ctr" indent="0" marL="0">
+              <a:buNone/>
+            </a:pPr>
+            <a:r>
+              <a:rPr lang="en-US" sz="1700" b="1" dirty="0">
                 <a:solidFill>
                   <a:srgbClr val="FFFFFF"/>
                 </a:solidFill>
@@ -4062,20 +4899,20 @@
               </a:rPr>
               <a:t>6</a:t>
             </a:r>
-            <a:endParaRPr lang="en-US" sz="2200" dirty="0"/>
+            <a:endParaRPr lang="en-US" sz="1700" dirty="0"/>
           </a:p>
         </p:txBody>
       </p:sp>
       <p:sp>
         <p:nvSpPr>
-          <p:cNvPr id="27" name="Text 25"/>
-          <p:cNvSpPr/>
-          <p:nvPr/>
-        </p:nvSpPr>
-        <p:spPr>
-          <a:xfrm>
-            <a:off x="6995160" y="4572000"/>
-            <a:ext cx="4663440" cy="411480"/>
+          <p:cNvPr id="50" name="Text 48"/>
+          <p:cNvSpPr/>
+          <p:nvPr/>
+        </p:nvSpPr>
+        <p:spPr>
+          <a:xfrm>
+            <a:off x="6675120" y="4251960"/>
+            <a:ext cx="1737360" cy="548640"/>
           </a:xfrm>
           <a:prstGeom prst="rect">
             <a:avLst/>
@@ -4091,7 +4928,815 @@
               <a:buNone/>
             </a:pPr>
             <a:r>
-              <a:rPr lang="en-US" sz="1600" b="1" dirty="0">
+              <a:rPr lang="en-US" sz="1350" b="1" dirty="0">
+                <a:solidFill>
+                  <a:srgbClr val="1B1B2F"/>
+                </a:solidFill>
+                <a:latin typeface="Segoe UI" pitchFamily="34" charset="0"/>
+                <a:ea typeface="Segoe UI" pitchFamily="34" charset="-122"/>
+                <a:cs typeface="Segoe UI" pitchFamily="34" charset="-120"/>
+              </a:rPr>
+              <a:t>Approve</a:t>
+            </a:r>
+            <a:endParaRPr lang="en-US" sz="1350" dirty="0"/>
+          </a:p>
+          <a:p>
+            <a:pPr indent="0" marL="0">
+              <a:buNone/>
+            </a:pPr>
+            <a:r>
+              <a:rPr lang="en-US" sz="1350" b="1" dirty="0">
+                <a:solidFill>
+                  <a:srgbClr val="1B1B2F"/>
+                </a:solidFill>
+                <a:latin typeface="Segoe UI" pitchFamily="34" charset="0"/>
+                <a:ea typeface="Segoe UI" pitchFamily="34" charset="-122"/>
+                <a:cs typeface="Segoe UI" pitchFamily="34" charset="-120"/>
+              </a:rPr>
+              <a:t>Rollback</a:t>
+            </a:r>
+            <a:endParaRPr lang="en-US" sz="1350" dirty="0"/>
+          </a:p>
+        </p:txBody>
+      </p:sp>
+      <p:sp>
+        <p:nvSpPr>
+          <p:cNvPr id="51" name="Text 49"/>
+          <p:cNvSpPr/>
+          <p:nvPr/>
+        </p:nvSpPr>
+        <p:spPr>
+          <a:xfrm>
+            <a:off x="6172200" y="4818888"/>
+            <a:ext cx="2194560" cy="502920"/>
+          </a:xfrm>
+          <a:prstGeom prst="rect">
+            <a:avLst/>
+          </a:prstGeom>
+          <a:noFill/>
+          <a:ln/>
+        </p:spPr>
+        <p:txBody>
+          <a:bodyPr wrap="square" rtlCol="0" anchor="t"/>
+          <a:lstStyle/>
+          <a:p>
+            <a:pPr indent="0" marL="0">
+              <a:buNone/>
+            </a:pPr>
+            <a:r>
+              <a:rPr lang="en-US" sz="1050" dirty="0">
+                <a:solidFill>
+                  <a:srgbClr val="5B6770"/>
+                </a:solidFill>
+                <a:latin typeface="Segoe UI" pitchFamily="34" charset="0"/>
+                <a:ea typeface="Segoe UI" pitchFamily="34" charset="-122"/>
+                <a:cs typeface="Segoe UI" pitchFamily="34" charset="-120"/>
+              </a:rPr>
+              <a:t>One click: 'Dismiss &amp; Rollback'</a:t>
+            </a:r>
+            <a:endParaRPr lang="en-US" sz="1050" dirty="0"/>
+          </a:p>
+        </p:txBody>
+      </p:sp>
+      <p:sp>
+        <p:nvSpPr>
+          <p:cNvPr id="52" name="Shape 50"/>
+          <p:cNvSpPr/>
+          <p:nvPr/>
+        </p:nvSpPr>
+        <p:spPr>
+          <a:xfrm>
+            <a:off x="7269480" y="5276088"/>
+            <a:ext cx="1143000" cy="237744"/>
+          </a:xfrm>
+          <a:prstGeom prst="roundRect">
+            <a:avLst>
+              <a:gd name="adj" fmla="val 11538"/>
+            </a:avLst>
+          </a:prstGeom>
+          <a:solidFill>
+            <a:srgbClr val="E65100"/>
+          </a:solidFill>
+          <a:ln/>
+        </p:spPr>
+      </p:sp>
+      <p:sp>
+        <p:nvSpPr>
+          <p:cNvPr id="53" name="Text 51"/>
+          <p:cNvSpPr/>
+          <p:nvPr/>
+        </p:nvSpPr>
+        <p:spPr>
+          <a:xfrm>
+            <a:off x="7269480" y="5276088"/>
+            <a:ext cx="1143000" cy="237744"/>
+          </a:xfrm>
+          <a:prstGeom prst="rect">
+            <a:avLst/>
+          </a:prstGeom>
+          <a:noFill/>
+          <a:ln/>
+        </p:spPr>
+        <p:txBody>
+          <a:bodyPr wrap="square" rtlCol="0" anchor="ctr"/>
+          <a:lstStyle/>
+          <a:p>
+            <a:pPr algn="ctr" indent="0" marL="0">
+              <a:buNone/>
+            </a:pPr>
+            <a:r>
+              <a:rPr lang="en-US" sz="850" b="1" dirty="0">
+                <a:solidFill>
+                  <a:srgbClr val="FFFFFF"/>
+                </a:solidFill>
+                <a:latin typeface="Segoe UI" pitchFamily="34" charset="0"/>
+                <a:ea typeface="Segoe UI" pitchFamily="34" charset="-122"/>
+                <a:cs typeface="Segoe UI" pitchFamily="34" charset="-120"/>
+              </a:rPr>
+              <a:t>User Intervention</a:t>
+            </a:r>
+            <a:endParaRPr lang="en-US" sz="850" dirty="0"/>
+          </a:p>
+        </p:txBody>
+      </p:sp>
+      <p:sp>
+        <p:nvSpPr>
+          <p:cNvPr id="54" name="Shape 52"/>
+          <p:cNvSpPr/>
+          <p:nvPr/>
+        </p:nvSpPr>
+        <p:spPr>
+          <a:xfrm>
+            <a:off x="3246120" y="4160520"/>
+            <a:ext cx="2468880" cy="1417320"/>
+          </a:xfrm>
+          <a:prstGeom prst="roundRect">
+            <a:avLst>
+              <a:gd name="adj" fmla="val 5161"/>
+            </a:avLst>
+          </a:prstGeom>
+          <a:solidFill>
+            <a:srgbClr val="E1F0FF"/>
+          </a:solidFill>
+          <a:ln w="22225">
+            <a:solidFill>
+              <a:srgbClr val="0D47A1"/>
+            </a:solidFill>
+            <a:prstDash val="solid"/>
+          </a:ln>
+        </p:spPr>
+      </p:sp>
+      <p:sp>
+        <p:nvSpPr>
+          <p:cNvPr id="55" name="Shape 53"/>
+          <p:cNvSpPr/>
+          <p:nvPr/>
+        </p:nvSpPr>
+        <p:spPr>
+          <a:xfrm>
+            <a:off x="3355848" y="4270248"/>
+            <a:ext cx="457200" cy="457200"/>
+          </a:xfrm>
+          <a:prstGeom prst="oval">
+            <a:avLst/>
+          </a:prstGeom>
+          <a:solidFill>
+            <a:srgbClr val="0D47A1"/>
+          </a:solidFill>
+          <a:ln/>
+        </p:spPr>
+      </p:sp>
+      <p:sp>
+        <p:nvSpPr>
+          <p:cNvPr id="56" name="Text 54"/>
+          <p:cNvSpPr/>
+          <p:nvPr/>
+        </p:nvSpPr>
+        <p:spPr>
+          <a:xfrm>
+            <a:off x="3355848" y="4270248"/>
+            <a:ext cx="457200" cy="457200"/>
+          </a:xfrm>
+          <a:prstGeom prst="rect">
+            <a:avLst/>
+          </a:prstGeom>
+          <a:noFill/>
+          <a:ln/>
+        </p:spPr>
+        <p:txBody>
+          <a:bodyPr wrap="square" rtlCol="0" anchor="ctr"/>
+          <a:lstStyle/>
+          <a:p>
+            <a:pPr algn="ctr" indent="0" marL="0">
+              <a:buNone/>
+            </a:pPr>
+            <a:r>
+              <a:rPr lang="en-US" sz="1700" b="1" dirty="0">
+                <a:solidFill>
+                  <a:srgbClr val="FFFFFF"/>
+                </a:solidFill>
+                <a:latin typeface="Segoe UI" pitchFamily="34" charset="0"/>
+                <a:ea typeface="Segoe UI" pitchFamily="34" charset="-122"/>
+                <a:cs typeface="Segoe UI" pitchFamily="34" charset="-120"/>
+              </a:rPr>
+              <a:t>7</a:t>
+            </a:r>
+            <a:endParaRPr lang="en-US" sz="1700" dirty="0"/>
+          </a:p>
+        </p:txBody>
+      </p:sp>
+      <p:sp>
+        <p:nvSpPr>
+          <p:cNvPr id="57" name="Text 55"/>
+          <p:cNvSpPr/>
+          <p:nvPr/>
+        </p:nvSpPr>
+        <p:spPr>
+          <a:xfrm>
+            <a:off x="3886200" y="4251960"/>
+            <a:ext cx="1737360" cy="548640"/>
+          </a:xfrm>
+          <a:prstGeom prst="rect">
+            <a:avLst/>
+          </a:prstGeom>
+          <a:noFill/>
+          <a:ln/>
+        </p:spPr>
+        <p:txBody>
+          <a:bodyPr wrap="square" rtlCol="0" anchor="ctr"/>
+          <a:lstStyle/>
+          <a:p>
+            <a:pPr indent="0" marL="0">
+              <a:buNone/>
+            </a:pPr>
+            <a:r>
+              <a:rPr lang="en-US" sz="1350" b="1" dirty="0">
+                <a:solidFill>
+                  <a:srgbClr val="1B1B2F"/>
+                </a:solidFill>
+                <a:latin typeface="Segoe UI" pitchFamily="34" charset="0"/>
+                <a:ea typeface="Segoe UI" pitchFamily="34" charset="-122"/>
+                <a:cs typeface="Segoe UI" pitchFamily="34" charset="-120"/>
+              </a:rPr>
+              <a:t>Patch +</a:t>
+            </a:r>
+            <a:endParaRPr lang="en-US" sz="1350" dirty="0"/>
+          </a:p>
+          <a:p>
+            <a:pPr indent="0" marL="0">
+              <a:buNone/>
+            </a:pPr>
+            <a:r>
+              <a:rPr lang="en-US" sz="1350" b="1" dirty="0">
+                <a:solidFill>
+                  <a:srgbClr val="1B1B2F"/>
+                </a:solidFill>
+                <a:latin typeface="Segoe UI" pitchFamily="34" charset="0"/>
+                <a:ea typeface="Segoe UI" pitchFamily="34" charset="-122"/>
+                <a:cs typeface="Segoe UI" pitchFamily="34" charset="-120"/>
+              </a:rPr>
+              <a:t>Restart</a:t>
+            </a:r>
+            <a:endParaRPr lang="en-US" sz="1350" dirty="0"/>
+          </a:p>
+        </p:txBody>
+      </p:sp>
+      <p:sp>
+        <p:nvSpPr>
+          <p:cNvPr id="58" name="Text 56"/>
+          <p:cNvSpPr/>
+          <p:nvPr/>
+        </p:nvSpPr>
+        <p:spPr>
+          <a:xfrm>
+            <a:off x="3383280" y="4818888"/>
+            <a:ext cx="2194560" cy="502920"/>
+          </a:xfrm>
+          <a:prstGeom prst="rect">
+            <a:avLst/>
+          </a:prstGeom>
+          <a:noFill/>
+          <a:ln/>
+        </p:spPr>
+        <p:txBody>
+          <a:bodyPr wrap="square" rtlCol="0" anchor="t"/>
+          <a:lstStyle/>
+          <a:p>
+            <a:pPr indent="0" marL="0">
+              <a:buNone/>
+            </a:pPr>
+            <a:r>
+              <a:rPr lang="en-US" sz="1050" dirty="0">
+                <a:solidFill>
+                  <a:srgbClr val="5B6770"/>
+                </a:solidFill>
+                <a:latin typeface="Segoe UI" pitchFamily="34" charset="0"/>
+                <a:ea typeface="Segoe UI" pitchFamily="34" charset="-122"/>
+                <a:cs typeface="Segoe UI" pitchFamily="34" charset="-120"/>
+              </a:rPr>
+              <a:t>Strategic-merge patch, rolling restart</a:t>
+            </a:r>
+            <a:endParaRPr lang="en-US" sz="1050" dirty="0"/>
+          </a:p>
+        </p:txBody>
+      </p:sp>
+      <p:sp>
+        <p:nvSpPr>
+          <p:cNvPr id="59" name="Shape 57"/>
+          <p:cNvSpPr/>
+          <p:nvPr/>
+        </p:nvSpPr>
+        <p:spPr>
+          <a:xfrm>
+            <a:off x="4480560" y="5276088"/>
+            <a:ext cx="1143000" cy="237744"/>
+          </a:xfrm>
+          <a:prstGeom prst="roundRect">
+            <a:avLst>
+              <a:gd name="adj" fmla="val 11538"/>
+            </a:avLst>
+          </a:prstGeom>
+          <a:solidFill>
+            <a:srgbClr val="0D47A1"/>
+          </a:solidFill>
+          <a:ln/>
+        </p:spPr>
+      </p:sp>
+      <p:sp>
+        <p:nvSpPr>
+          <p:cNvPr id="60" name="Text 58"/>
+          <p:cNvSpPr/>
+          <p:nvPr/>
+        </p:nvSpPr>
+        <p:spPr>
+          <a:xfrm>
+            <a:off x="4480560" y="5276088"/>
+            <a:ext cx="1143000" cy="237744"/>
+          </a:xfrm>
+          <a:prstGeom prst="rect">
+            <a:avLst/>
+          </a:prstGeom>
+          <a:noFill/>
+          <a:ln/>
+        </p:spPr>
+        <p:txBody>
+          <a:bodyPr wrap="square" rtlCol="0" anchor="ctr"/>
+          <a:lstStyle/>
+          <a:p>
+            <a:pPr algn="ctr" indent="0" marL="0">
+              <a:buNone/>
+            </a:pPr>
+            <a:r>
+              <a:rPr lang="en-US" sz="850" b="1" dirty="0">
+                <a:solidFill>
+                  <a:srgbClr val="FFFFFF"/>
+                </a:solidFill>
+                <a:latin typeface="Segoe UI" pitchFamily="34" charset="0"/>
+                <a:ea typeface="Segoe UI" pitchFamily="34" charset="-122"/>
+                <a:cs typeface="Segoe UI" pitchFamily="34" charset="-120"/>
+              </a:rPr>
+              <a:t>Automated</a:t>
+            </a:r>
+            <a:endParaRPr lang="en-US" sz="850" dirty="0"/>
+          </a:p>
+        </p:txBody>
+      </p:sp>
+      <p:sp>
+        <p:nvSpPr>
+          <p:cNvPr id="61" name="Shape 59"/>
+          <p:cNvSpPr/>
+          <p:nvPr/>
+        </p:nvSpPr>
+        <p:spPr>
+          <a:xfrm>
+            <a:off x="457200" y="4160520"/>
+            <a:ext cx="2468880" cy="1417320"/>
+          </a:xfrm>
+          <a:prstGeom prst="roundRect">
+            <a:avLst>
+              <a:gd name="adj" fmla="val 5161"/>
+            </a:avLst>
+          </a:prstGeom>
+          <a:solidFill>
+            <a:srgbClr val="E1F0FF"/>
+          </a:solidFill>
+          <a:ln w="22225">
+            <a:solidFill>
+              <a:srgbClr val="0D47A1"/>
+            </a:solidFill>
+            <a:prstDash val="solid"/>
+          </a:ln>
+        </p:spPr>
+      </p:sp>
+      <p:sp>
+        <p:nvSpPr>
+          <p:cNvPr id="62" name="Shape 60"/>
+          <p:cNvSpPr/>
+          <p:nvPr/>
+        </p:nvSpPr>
+        <p:spPr>
+          <a:xfrm>
+            <a:off x="566928" y="4270248"/>
+            <a:ext cx="457200" cy="457200"/>
+          </a:xfrm>
+          <a:prstGeom prst="oval">
+            <a:avLst/>
+          </a:prstGeom>
+          <a:solidFill>
+            <a:srgbClr val="0D47A1"/>
+          </a:solidFill>
+          <a:ln/>
+        </p:spPr>
+      </p:sp>
+      <p:sp>
+        <p:nvSpPr>
+          <p:cNvPr id="63" name="Text 61"/>
+          <p:cNvSpPr/>
+          <p:nvPr/>
+        </p:nvSpPr>
+        <p:spPr>
+          <a:xfrm>
+            <a:off x="566928" y="4270248"/>
+            <a:ext cx="457200" cy="457200"/>
+          </a:xfrm>
+          <a:prstGeom prst="rect">
+            <a:avLst/>
+          </a:prstGeom>
+          <a:noFill/>
+          <a:ln/>
+        </p:spPr>
+        <p:txBody>
+          <a:bodyPr wrap="square" rtlCol="0" anchor="ctr"/>
+          <a:lstStyle/>
+          <a:p>
+            <a:pPr algn="ctr" indent="0" marL="0">
+              <a:buNone/>
+            </a:pPr>
+            <a:r>
+              <a:rPr lang="en-US" sz="1700" b="1" dirty="0">
+                <a:solidFill>
+                  <a:srgbClr val="FFFFFF"/>
+                </a:solidFill>
+                <a:latin typeface="Segoe UI" pitchFamily="34" charset="0"/>
+                <a:ea typeface="Segoe UI" pitchFamily="34" charset="-122"/>
+                <a:cs typeface="Segoe UI" pitchFamily="34" charset="-120"/>
+              </a:rPr>
+              <a:t>8</a:t>
+            </a:r>
+            <a:endParaRPr lang="en-US" sz="1700" dirty="0"/>
+          </a:p>
+        </p:txBody>
+      </p:sp>
+      <p:sp>
+        <p:nvSpPr>
+          <p:cNvPr id="64" name="Text 62"/>
+          <p:cNvSpPr/>
+          <p:nvPr/>
+        </p:nvSpPr>
+        <p:spPr>
+          <a:xfrm>
+            <a:off x="1097280" y="4251960"/>
+            <a:ext cx="1737360" cy="548640"/>
+          </a:xfrm>
+          <a:prstGeom prst="rect">
+            <a:avLst/>
+          </a:prstGeom>
+          <a:noFill/>
+          <a:ln/>
+        </p:spPr>
+        <p:txBody>
+          <a:bodyPr wrap="square" rtlCol="0" anchor="ctr"/>
+          <a:lstStyle/>
+          <a:p>
+            <a:pPr indent="0" marL="0">
+              <a:buNone/>
+            </a:pPr>
+            <a:r>
+              <a:rPr lang="en-US" sz="1350" b="1" dirty="0">
+                <a:solidFill>
+                  <a:srgbClr val="1B1B2F"/>
+                </a:solidFill>
+                <a:latin typeface="Segoe UI" pitchFamily="34" charset="0"/>
+                <a:ea typeface="Segoe UI" pitchFamily="34" charset="-122"/>
+                <a:cs typeface="Segoe UI" pitchFamily="34" charset="-120"/>
+              </a:rPr>
+              <a:t>Verify &amp;</a:t>
+            </a:r>
+            <a:endParaRPr lang="en-US" sz="1350" dirty="0"/>
+          </a:p>
+          <a:p>
+            <a:pPr indent="0" marL="0">
+              <a:buNone/>
+            </a:pPr>
+            <a:r>
+              <a:rPr lang="en-US" sz="1350" b="1" dirty="0">
+                <a:solidFill>
+                  <a:srgbClr val="1B1B2F"/>
+                </a:solidFill>
+                <a:latin typeface="Segoe UI" pitchFamily="34" charset="0"/>
+                <a:ea typeface="Segoe UI" pitchFamily="34" charset="-122"/>
+                <a:cs typeface="Segoe UI" pitchFamily="34" charset="-120"/>
+              </a:rPr>
+              <a:t>Audit</a:t>
+            </a:r>
+            <a:endParaRPr lang="en-US" sz="1350" dirty="0"/>
+          </a:p>
+        </p:txBody>
+      </p:sp>
+      <p:sp>
+        <p:nvSpPr>
+          <p:cNvPr id="65" name="Text 63"/>
+          <p:cNvSpPr/>
+          <p:nvPr/>
+        </p:nvSpPr>
+        <p:spPr>
+          <a:xfrm>
+            <a:off x="594360" y="4818888"/>
+            <a:ext cx="2194560" cy="502920"/>
+          </a:xfrm>
+          <a:prstGeom prst="rect">
+            <a:avLst/>
+          </a:prstGeom>
+          <a:noFill/>
+          <a:ln/>
+        </p:spPr>
+        <p:txBody>
+          <a:bodyPr wrap="square" rtlCol="0" anchor="t"/>
+          <a:lstStyle/>
+          <a:p>
+            <a:pPr indent="0" marL="0">
+              <a:buNone/>
+            </a:pPr>
+            <a:r>
+              <a:rPr lang="en-US" sz="1050" dirty="0">
+                <a:solidFill>
+                  <a:srgbClr val="5B6770"/>
+                </a:solidFill>
+                <a:latin typeface="Segoe UI" pitchFamily="34" charset="0"/>
+                <a:ea typeface="Segoe UI" pitchFamily="34" charset="-122"/>
+                <a:cs typeface="Segoe UI" pitchFamily="34" charset="-120"/>
+              </a:rPr>
+              <a:t>Health confirmed, logged 90 days</a:t>
+            </a:r>
+            <a:endParaRPr lang="en-US" sz="1050" dirty="0"/>
+          </a:p>
+        </p:txBody>
+      </p:sp>
+      <p:sp>
+        <p:nvSpPr>
+          <p:cNvPr id="66" name="Shape 64"/>
+          <p:cNvSpPr/>
+          <p:nvPr/>
+        </p:nvSpPr>
+        <p:spPr>
+          <a:xfrm>
+            <a:off x="1691640" y="5276088"/>
+            <a:ext cx="1143000" cy="237744"/>
+          </a:xfrm>
+          <a:prstGeom prst="roundRect">
+            <a:avLst>
+              <a:gd name="adj" fmla="val 11538"/>
+            </a:avLst>
+          </a:prstGeom>
+          <a:solidFill>
+            <a:srgbClr val="0D47A1"/>
+          </a:solidFill>
+          <a:ln/>
+        </p:spPr>
+      </p:sp>
+      <p:sp>
+        <p:nvSpPr>
+          <p:cNvPr id="67" name="Text 65"/>
+          <p:cNvSpPr/>
+          <p:nvPr/>
+        </p:nvSpPr>
+        <p:spPr>
+          <a:xfrm>
+            <a:off x="1691640" y="5276088"/>
+            <a:ext cx="1143000" cy="237744"/>
+          </a:xfrm>
+          <a:prstGeom prst="rect">
+            <a:avLst/>
+          </a:prstGeom>
+          <a:noFill/>
+          <a:ln/>
+        </p:spPr>
+        <p:txBody>
+          <a:bodyPr wrap="square" rtlCol="0" anchor="ctr"/>
+          <a:lstStyle/>
+          <a:p>
+            <a:pPr algn="ctr" indent="0" marL="0">
+              <a:buNone/>
+            </a:pPr>
+            <a:r>
+              <a:rPr lang="en-US" sz="850" b="1" dirty="0">
+                <a:solidFill>
+                  <a:srgbClr val="FFFFFF"/>
+                </a:solidFill>
+                <a:latin typeface="Segoe UI" pitchFamily="34" charset="0"/>
+                <a:ea typeface="Segoe UI" pitchFamily="34" charset="-122"/>
+                <a:cs typeface="Segoe UI" pitchFamily="34" charset="-120"/>
+              </a:rPr>
+              <a:t>Automated</a:t>
+            </a:r>
+            <a:endParaRPr lang="en-US" sz="850" dirty="0"/>
+          </a:p>
+        </p:txBody>
+      </p:sp>
+      <p:sp>
+        <p:nvSpPr>
+          <p:cNvPr id="68" name="Shape 66"/>
+          <p:cNvSpPr/>
+          <p:nvPr/>
+        </p:nvSpPr>
+        <p:spPr>
+          <a:xfrm>
+            <a:off x="2926080" y="2674620"/>
+            <a:ext cx="320040" cy="0"/>
+          </a:xfrm>
+          <a:prstGeom prst="line">
+            <a:avLst/>
+          </a:prstGeom>
+          <a:noFill/>
+          <a:ln w="31750">
+            <a:solidFill>
+              <a:srgbClr val="0D47A1"/>
+            </a:solidFill>
+            <a:prstDash val="solid"/>
+            <a:tailEnd type="triangle"/>
+          </a:ln>
+        </p:spPr>
+      </p:sp>
+      <p:sp>
+        <p:nvSpPr>
+          <p:cNvPr id="69" name="Shape 67"/>
+          <p:cNvSpPr/>
+          <p:nvPr/>
+        </p:nvSpPr>
+        <p:spPr>
+          <a:xfrm>
+            <a:off x="5715000" y="2674620"/>
+            <a:ext cx="320040" cy="0"/>
+          </a:xfrm>
+          <a:prstGeom prst="line">
+            <a:avLst/>
+          </a:prstGeom>
+          <a:noFill/>
+          <a:ln w="31750">
+            <a:solidFill>
+              <a:srgbClr val="0D47A1"/>
+            </a:solidFill>
+            <a:prstDash val="solid"/>
+            <a:tailEnd type="triangle"/>
+          </a:ln>
+        </p:spPr>
+      </p:sp>
+      <p:sp>
+        <p:nvSpPr>
+          <p:cNvPr id="70" name="Shape 68"/>
+          <p:cNvSpPr/>
+          <p:nvPr/>
+        </p:nvSpPr>
+        <p:spPr>
+          <a:xfrm>
+            <a:off x="8503920" y="2674620"/>
+            <a:ext cx="320040" cy="0"/>
+          </a:xfrm>
+          <a:prstGeom prst="line">
+            <a:avLst/>
+          </a:prstGeom>
+          <a:noFill/>
+          <a:ln w="31750">
+            <a:solidFill>
+              <a:srgbClr val="0D47A1"/>
+            </a:solidFill>
+            <a:prstDash val="solid"/>
+            <a:tailEnd type="triangle"/>
+          </a:ln>
+        </p:spPr>
+      </p:sp>
+      <p:sp>
+        <p:nvSpPr>
+          <p:cNvPr id="71" name="Shape 69"/>
+          <p:cNvSpPr/>
+          <p:nvPr/>
+        </p:nvSpPr>
+        <p:spPr>
+          <a:xfrm>
+            <a:off x="10058400" y="3383280"/>
+            <a:ext cx="0" cy="777240"/>
+          </a:xfrm>
+          <a:prstGeom prst="line">
+            <a:avLst/>
+          </a:prstGeom>
+          <a:noFill/>
+          <a:ln w="31750">
+            <a:solidFill>
+              <a:srgbClr val="E65100"/>
+            </a:solidFill>
+            <a:prstDash val="solid"/>
+            <a:tailEnd type="triangle"/>
+          </a:ln>
+        </p:spPr>
+      </p:sp>
+      <p:sp>
+        <p:nvSpPr>
+          <p:cNvPr id="72" name="Shape 70"/>
+          <p:cNvSpPr/>
+          <p:nvPr/>
+        </p:nvSpPr>
+        <p:spPr>
+          <a:xfrm>
+            <a:off x="8503920" y="4869180"/>
+            <a:ext cx="320040" cy="0"/>
+          </a:xfrm>
+          <a:prstGeom prst="line">
+            <a:avLst/>
+          </a:prstGeom>
+          <a:noFill/>
+          <a:ln w="31750">
+            <a:solidFill>
+              <a:srgbClr val="E65100"/>
+            </a:solidFill>
+            <a:prstDash val="solid"/>
+            <a:headEnd type="triangle"/>
+          </a:ln>
+        </p:spPr>
+      </p:sp>
+      <p:sp>
+        <p:nvSpPr>
+          <p:cNvPr id="73" name="Shape 71"/>
+          <p:cNvSpPr/>
+          <p:nvPr/>
+        </p:nvSpPr>
+        <p:spPr>
+          <a:xfrm>
+            <a:off x="5715000" y="4869180"/>
+            <a:ext cx="320040" cy="0"/>
+          </a:xfrm>
+          <a:prstGeom prst="line">
+            <a:avLst/>
+          </a:prstGeom>
+          <a:noFill/>
+          <a:ln w="31750">
+            <a:solidFill>
+              <a:srgbClr val="E65100"/>
+            </a:solidFill>
+            <a:prstDash val="solid"/>
+            <a:headEnd type="triangle"/>
+          </a:ln>
+        </p:spPr>
+      </p:sp>
+      <p:sp>
+        <p:nvSpPr>
+          <p:cNvPr id="74" name="Shape 72"/>
+          <p:cNvSpPr/>
+          <p:nvPr/>
+        </p:nvSpPr>
+        <p:spPr>
+          <a:xfrm>
+            <a:off x="2926080" y="4869180"/>
+            <a:ext cx="320040" cy="0"/>
+          </a:xfrm>
+          <a:prstGeom prst="line">
+            <a:avLst/>
+          </a:prstGeom>
+          <a:noFill/>
+          <a:ln w="31750">
+            <a:solidFill>
+              <a:srgbClr val="E65100"/>
+            </a:solidFill>
+            <a:prstDash val="solid"/>
+            <a:headEnd type="triangle"/>
+          </a:ln>
+        </p:spPr>
+      </p:sp>
+      <p:sp>
+        <p:nvSpPr>
+          <p:cNvPr id="75" name="Text 73"/>
+          <p:cNvSpPr/>
+          <p:nvPr/>
+        </p:nvSpPr>
+        <p:spPr>
+          <a:xfrm>
+            <a:off x="548640" y="5897880"/>
+            <a:ext cx="11064240" cy="365760"/>
+          </a:xfrm>
+          <a:prstGeom prst="rect">
+            <a:avLst/>
+          </a:prstGeom>
+          <a:noFill/>
+          <a:ln/>
+        </p:spPr>
+        <p:txBody>
+          <a:bodyPr wrap="square" rtlCol="0" anchor="ctr"/>
+          <a:lstStyle/>
+          <a:p>
+            <a:pPr algn="ctr" indent="0" marL="0">
+              <a:buNone/>
+            </a:pPr>
+            <a:r>
+              <a:rPr lang="en-US" sz="1300" b="1" i="1" dirty="0">
                 <a:solidFill>
                   <a:srgbClr val="1A237E"/>
                 </a:solidFill>
@@ -4099,48 +5744,9 @@
                 <a:ea typeface="Segoe UI" pitchFamily="34" charset="-122"/>
                 <a:cs typeface="Segoe UI" pitchFamily="34" charset="-120"/>
               </a:rPr>
-              <a:t>Verify &amp; Audit</a:t>
-            </a:r>
-            <a:endParaRPr lang="en-US" sz="1600" dirty="0"/>
-          </a:p>
-        </p:txBody>
-      </p:sp>
-      <p:sp>
-        <p:nvSpPr>
-          <p:cNvPr id="28" name="Text 26"/>
-          <p:cNvSpPr/>
-          <p:nvPr/>
-        </p:nvSpPr>
-        <p:spPr>
-          <a:xfrm>
-            <a:off x="6995160" y="4983480"/>
-            <a:ext cx="4663440" cy="822960"/>
-          </a:xfrm>
-          <a:prstGeom prst="rect">
-            <a:avLst/>
-          </a:prstGeom>
-          <a:noFill/>
-          <a:ln/>
-        </p:spPr>
-        <p:txBody>
-          <a:bodyPr wrap="square" rtlCol="0" anchor="ctr"/>
-          <a:lstStyle/>
-          <a:p>
-            <a:pPr indent="0" marL="0">
-              <a:buNone/>
-            </a:pPr>
-            <a:r>
-              <a:rPr lang="en-US" sz="1250" dirty="0">
-                <a:solidFill>
-                  <a:srgbClr val="5B6770"/>
-                </a:solidFill>
-                <a:latin typeface="Segoe UI" pitchFamily="34" charset="0"/>
-                <a:ea typeface="Segoe UI" pitchFamily="34" charset="-122"/>
-                <a:cs typeface="Segoe UI" pitchFamily="34" charset="-120"/>
-              </a:rPr>
-              <a:t>Counters update live, card marked 'ROLLED BACK', event written to audit trail.</a:t>
-            </a:r>
-            <a:endParaRPr lang="en-US" sz="1250" dirty="0"/>
+              <a:t>AI runs steps 2–4 autonomously  →  you approve at steps 5–6  →  the system executes &amp; verifies steps 7–8.</a:t>
+            </a:r>
+            <a:endParaRPr lang="en-US" sz="1300" dirty="0"/>
           </a:p>
         </p:txBody>
       </p:sp>
@@ -4184,6 +5790,431 @@
             <a:avLst/>
           </a:prstGeom>
           <a:solidFill>
+            <a:srgbClr val="00695C"/>
+          </a:solidFill>
+          <a:ln/>
+        </p:spPr>
+      </p:sp>
+      <p:sp>
+        <p:nvSpPr>
+          <p:cNvPr id="3" name="Text 1"/>
+          <p:cNvSpPr/>
+          <p:nvPr/>
+        </p:nvSpPr>
+        <p:spPr>
+          <a:xfrm>
+            <a:off x="548640" y="292608"/>
+            <a:ext cx="10058400" cy="320040"/>
+          </a:xfrm>
+          <a:prstGeom prst="rect">
+            <a:avLst/>
+          </a:prstGeom>
+          <a:noFill/>
+          <a:ln/>
+        </p:spPr>
+        <p:txBody>
+          <a:bodyPr wrap="square" rtlCol="0" anchor="ctr"/>
+          <a:lstStyle/>
+          <a:p>
+            <a:pPr indent="0" marL="0">
+              <a:buNone/>
+            </a:pPr>
+            <a:r>
+              <a:rPr lang="en-US" sz="1300" b="1" spc="200" kern="0" dirty="0">
+                <a:solidFill>
+                  <a:srgbClr val="00695C"/>
+                </a:solidFill>
+                <a:latin typeface="Segoe UI" pitchFamily="34" charset="0"/>
+                <a:ea typeface="Segoe UI" pitchFamily="34" charset="-122"/>
+                <a:cs typeface="Segoe UI" pitchFamily="34" charset="-120"/>
+              </a:rPr>
+              <a:t>WHO DOES WHAT</a:t>
+            </a:r>
+            <a:endParaRPr lang="en-US" sz="1300" dirty="0"/>
+          </a:p>
+        </p:txBody>
+      </p:sp>
+      <p:sp>
+        <p:nvSpPr>
+          <p:cNvPr id="4" name="Text 2"/>
+          <p:cNvSpPr/>
+          <p:nvPr/>
+        </p:nvSpPr>
+        <p:spPr>
+          <a:xfrm>
+            <a:off x="548640" y="603504"/>
+            <a:ext cx="10972800" cy="640080"/>
+          </a:xfrm>
+          <a:prstGeom prst="rect">
+            <a:avLst/>
+          </a:prstGeom>
+          <a:noFill/>
+          <a:ln/>
+        </p:spPr>
+        <p:txBody>
+          <a:bodyPr wrap="square" rtlCol="0" anchor="ctr"/>
+          <a:lstStyle/>
+          <a:p>
+            <a:pPr indent="0" marL="0">
+              <a:buNone/>
+            </a:pPr>
+            <a:r>
+              <a:rPr lang="en-US" sz="2700" b="1" dirty="0">
+                <a:solidFill>
+                  <a:srgbClr val="1B1B2F"/>
+                </a:solidFill>
+                <a:latin typeface="Segoe UI" pitchFamily="34" charset="0"/>
+                <a:ea typeface="Segoe UI" pitchFamily="34" charset="-122"/>
+                <a:cs typeface="Segoe UI" pitchFamily="34" charset="-120"/>
+              </a:rPr>
+              <a:t>Division of work: AI · Automated · User</a:t>
+            </a:r>
+            <a:endParaRPr lang="en-US" sz="2700" dirty="0"/>
+          </a:p>
+        </p:txBody>
+      </p:sp>
+      <p:sp>
+        <p:nvSpPr>
+          <p:cNvPr id="5" name="Shape 3"/>
+          <p:cNvSpPr/>
+          <p:nvPr/>
+        </p:nvSpPr>
+        <p:spPr>
+          <a:xfrm>
+            <a:off x="548640" y="1600200"/>
+            <a:ext cx="2194560" cy="1371600"/>
+          </a:xfrm>
+          <a:prstGeom prst="roundRect">
+            <a:avLst>
+              <a:gd name="adj" fmla="val 5333"/>
+            </a:avLst>
+          </a:prstGeom>
+          <a:solidFill>
+            <a:srgbClr val="00695C"/>
+          </a:solidFill>
+          <a:ln/>
+        </p:spPr>
+      </p:sp>
+      <p:sp>
+        <p:nvSpPr>
+          <p:cNvPr id="6" name="Text 4"/>
+          <p:cNvSpPr/>
+          <p:nvPr/>
+        </p:nvSpPr>
+        <p:spPr>
+          <a:xfrm>
+            <a:off x="548640" y="1737360"/>
+            <a:ext cx="2194560" cy="548640"/>
+          </a:xfrm>
+          <a:prstGeom prst="rect">
+            <a:avLst/>
+          </a:prstGeom>
+          <a:noFill/>
+          <a:ln/>
+        </p:spPr>
+        <p:txBody>
+          <a:bodyPr wrap="square" rtlCol="0" anchor="ctr"/>
+          <a:lstStyle/>
+          <a:p>
+            <a:pPr algn="ctr" indent="0" marL="0">
+              <a:buNone/>
+            </a:pPr>
+            <a:r>
+              <a:rPr lang="en-US" sz="1700" b="1" dirty="0">
+                <a:solidFill>
+                  <a:srgbClr val="FFFFFF"/>
+                </a:solidFill>
+                <a:latin typeface="Segoe UI" pitchFamily="34" charset="0"/>
+                <a:ea typeface="Segoe UI" pitchFamily="34" charset="-122"/>
+                <a:cs typeface="Segoe UI" pitchFamily="34" charset="-120"/>
+              </a:rPr>
+              <a:t>AI Agent</a:t>
+            </a:r>
+            <a:endParaRPr lang="en-US" sz="1700" dirty="0"/>
+          </a:p>
+        </p:txBody>
+      </p:sp>
+      <p:sp>
+        <p:nvSpPr>
+          <p:cNvPr id="7" name="Text 5"/>
+          <p:cNvSpPr/>
+          <p:nvPr/>
+        </p:nvSpPr>
+        <p:spPr>
+          <a:xfrm>
+            <a:off x="640080" y="2258568"/>
+            <a:ext cx="2011680" cy="640080"/>
+          </a:xfrm>
+          <a:prstGeom prst="rect">
+            <a:avLst/>
+          </a:prstGeom>
+          <a:noFill/>
+          <a:ln/>
+        </p:spPr>
+        <p:txBody>
+          <a:bodyPr wrap="square" rtlCol="0" anchor="ctr"/>
+          <a:lstStyle/>
+          <a:p>
+            <a:pPr algn="ctr" indent="0" marL="0">
+              <a:buNone/>
+            </a:pPr>
+            <a:r>
+              <a:rPr lang="en-US" sz="1050" i="1" dirty="0">
+                <a:solidFill>
+                  <a:srgbClr val="FFFFFF"/>
+                </a:solidFill>
+                <a:latin typeface="Segoe UI" pitchFamily="34" charset="0"/>
+                <a:ea typeface="Segoe UI" pitchFamily="34" charset="-122"/>
+                <a:cs typeface="Segoe UI" pitchFamily="34" charset="-120"/>
+              </a:rPr>
+              <a:t>Autonomous — no human polling or diffing</a:t>
+            </a:r>
+            <a:endParaRPr lang="en-US" sz="1050" dirty="0"/>
+          </a:p>
+        </p:txBody>
+      </p:sp>
+      <p:sp>
+        <p:nvSpPr>
+          <p:cNvPr id="8" name="Shape 6"/>
+          <p:cNvSpPr/>
+          <p:nvPr/>
+        </p:nvSpPr>
+        <p:spPr>
+          <a:xfrm>
+            <a:off x="2880360" y="1600200"/>
+            <a:ext cx="8732520" cy="1371600"/>
+          </a:xfrm>
+          <a:prstGeom prst="roundRect">
+            <a:avLst>
+              <a:gd name="adj" fmla="val 5333"/>
+            </a:avLst>
+          </a:prstGeom>
+          <a:solidFill>
+            <a:srgbClr val="E0F2F1"/>
+          </a:solidFill>
+          <a:ln w="15875">
+            <a:solidFill>
+              <a:srgbClr val="00695C"/>
+            </a:solidFill>
+            <a:prstDash val="solid"/>
+          </a:ln>
+        </p:spPr>
+      </p:sp>
+      <p:sp>
+        <p:nvSpPr>
+          <p:cNvPr id="9" name="Shape 7"/>
+          <p:cNvSpPr/>
+          <p:nvPr/>
+        </p:nvSpPr>
+        <p:spPr>
+          <a:xfrm>
+            <a:off x="3017520" y="1874520"/>
+            <a:ext cx="2560320" cy="822960"/>
+          </a:xfrm>
+          <a:prstGeom prst="roundRect">
+            <a:avLst>
+              <a:gd name="adj" fmla="val 6667"/>
+            </a:avLst>
+          </a:prstGeom>
+          <a:solidFill>
+            <a:srgbClr val="FFFFFF"/>
+          </a:solidFill>
+          <a:ln w="12700">
+            <a:solidFill>
+              <a:srgbClr val="00695C"/>
+            </a:solidFill>
+            <a:prstDash val="solid"/>
+          </a:ln>
+        </p:spPr>
+      </p:sp>
+      <p:sp>
+        <p:nvSpPr>
+          <p:cNvPr id="10" name="Text 8"/>
+          <p:cNvSpPr/>
+          <p:nvPr/>
+        </p:nvSpPr>
+        <p:spPr>
+          <a:xfrm>
+            <a:off x="3063240" y="1874520"/>
+            <a:ext cx="2468880" cy="822960"/>
+          </a:xfrm>
+          <a:prstGeom prst="rect">
+            <a:avLst/>
+          </a:prstGeom>
+          <a:noFill/>
+          <a:ln/>
+        </p:spPr>
+        <p:txBody>
+          <a:bodyPr wrap="square" rtlCol="0" anchor="ctr"/>
+          <a:lstStyle/>
+          <a:p>
+            <a:pPr algn="ctr" indent="0" marL="0">
+              <a:buNone/>
+            </a:pPr>
+            <a:r>
+              <a:rPr lang="en-US" sz="1300" b="1" dirty="0">
+                <a:solidFill>
+                  <a:srgbClr val="1B1B2F"/>
+                </a:solidFill>
+                <a:latin typeface="Segoe UI" pitchFamily="34" charset="0"/>
+                <a:ea typeface="Segoe UI" pitchFamily="34" charset="-122"/>
+                <a:cs typeface="Segoe UI" pitchFamily="34" charset="-120"/>
+              </a:rPr>
+              <a:t>2. Continuous Watch</a:t>
+            </a:r>
+            <a:endParaRPr lang="en-US" sz="1300" dirty="0"/>
+          </a:p>
+        </p:txBody>
+      </p:sp>
+      <p:sp>
+        <p:nvSpPr>
+          <p:cNvPr id="11" name="Shape 9"/>
+          <p:cNvSpPr/>
+          <p:nvPr/>
+        </p:nvSpPr>
+        <p:spPr>
+          <a:xfrm>
+            <a:off x="5806440" y="1874520"/>
+            <a:ext cx="2560320" cy="822960"/>
+          </a:xfrm>
+          <a:prstGeom prst="roundRect">
+            <a:avLst>
+              <a:gd name="adj" fmla="val 6667"/>
+            </a:avLst>
+          </a:prstGeom>
+          <a:solidFill>
+            <a:srgbClr val="FFFFFF"/>
+          </a:solidFill>
+          <a:ln w="12700">
+            <a:solidFill>
+              <a:srgbClr val="00695C"/>
+            </a:solidFill>
+            <a:prstDash val="solid"/>
+          </a:ln>
+        </p:spPr>
+      </p:sp>
+      <p:sp>
+        <p:nvSpPr>
+          <p:cNvPr id="12" name="Text 10"/>
+          <p:cNvSpPr/>
+          <p:nvPr/>
+        </p:nvSpPr>
+        <p:spPr>
+          <a:xfrm>
+            <a:off x="5852160" y="1874520"/>
+            <a:ext cx="2468880" cy="822960"/>
+          </a:xfrm>
+          <a:prstGeom prst="rect">
+            <a:avLst/>
+          </a:prstGeom>
+          <a:noFill/>
+          <a:ln/>
+        </p:spPr>
+        <p:txBody>
+          <a:bodyPr wrap="square" rtlCol="0" anchor="ctr"/>
+          <a:lstStyle/>
+          <a:p>
+            <a:pPr algn="ctr" indent="0" marL="0">
+              <a:buNone/>
+            </a:pPr>
+            <a:r>
+              <a:rPr lang="en-US" sz="1300" b="1" dirty="0">
+                <a:solidFill>
+                  <a:srgbClr val="1B1B2F"/>
+                </a:solidFill>
+                <a:latin typeface="Segoe UI" pitchFamily="34" charset="0"/>
+                <a:ea typeface="Segoe UI" pitchFamily="34" charset="-122"/>
+                <a:cs typeface="Segoe UI" pitchFamily="34" charset="-120"/>
+              </a:rPr>
+              <a:t>3. Drift Detected</a:t>
+            </a:r>
+            <a:endParaRPr lang="en-US" sz="1300" dirty="0"/>
+          </a:p>
+        </p:txBody>
+      </p:sp>
+      <p:sp>
+        <p:nvSpPr>
+          <p:cNvPr id="13" name="Shape 11"/>
+          <p:cNvSpPr/>
+          <p:nvPr/>
+        </p:nvSpPr>
+        <p:spPr>
+          <a:xfrm>
+            <a:off x="8595360" y="1874520"/>
+            <a:ext cx="2560320" cy="822960"/>
+          </a:xfrm>
+          <a:prstGeom prst="roundRect">
+            <a:avLst>
+              <a:gd name="adj" fmla="val 6667"/>
+            </a:avLst>
+          </a:prstGeom>
+          <a:solidFill>
+            <a:srgbClr val="FFFFFF"/>
+          </a:solidFill>
+          <a:ln w="12700">
+            <a:solidFill>
+              <a:srgbClr val="00695C"/>
+            </a:solidFill>
+            <a:prstDash val="solid"/>
+          </a:ln>
+        </p:spPr>
+      </p:sp>
+      <p:sp>
+        <p:nvSpPr>
+          <p:cNvPr id="14" name="Text 12"/>
+          <p:cNvSpPr/>
+          <p:nvPr/>
+        </p:nvSpPr>
+        <p:spPr>
+          <a:xfrm>
+            <a:off x="8641080" y="1874520"/>
+            <a:ext cx="2468880" cy="822960"/>
+          </a:xfrm>
+          <a:prstGeom prst="rect">
+            <a:avLst/>
+          </a:prstGeom>
+          <a:noFill/>
+          <a:ln/>
+        </p:spPr>
+        <p:txBody>
+          <a:bodyPr wrap="square" rtlCol="0" anchor="ctr"/>
+          <a:lstStyle/>
+          <a:p>
+            <a:pPr algn="ctr" indent="0" marL="0">
+              <a:buNone/>
+            </a:pPr>
+            <a:r>
+              <a:rPr lang="en-US" sz="1300" b="1" dirty="0">
+                <a:solidFill>
+                  <a:srgbClr val="1B1B2F"/>
+                </a:solidFill>
+                <a:latin typeface="Segoe UI" pitchFamily="34" charset="0"/>
+                <a:ea typeface="Segoe UI" pitchFamily="34" charset="-122"/>
+                <a:cs typeface="Segoe UI" pitchFamily="34" charset="-120"/>
+              </a:rPr>
+              <a:t>4. Explain Change (LLM)</a:t>
+            </a:r>
+            <a:endParaRPr lang="en-US" sz="1300" dirty="0"/>
+          </a:p>
+        </p:txBody>
+      </p:sp>
+      <p:sp>
+        <p:nvSpPr>
+          <p:cNvPr id="15" name="Shape 13"/>
+          <p:cNvSpPr/>
+          <p:nvPr/>
+        </p:nvSpPr>
+        <p:spPr>
+          <a:xfrm>
+            <a:off x="548640" y="3154680"/>
+            <a:ext cx="2194560" cy="1371600"/>
+          </a:xfrm>
+          <a:prstGeom prst="roundRect">
+            <a:avLst>
+              <a:gd name="adj" fmla="val 5333"/>
+            </a:avLst>
+          </a:prstGeom>
+          <a:solidFill>
             <a:srgbClr val="E65100"/>
           </a:solidFill>
           <a:ln/>
@@ -4191,13 +6222,659 @@
       </p:sp>
       <p:sp>
         <p:nvSpPr>
+          <p:cNvPr id="16" name="Text 14"/>
+          <p:cNvSpPr/>
+          <p:nvPr/>
+        </p:nvSpPr>
+        <p:spPr>
+          <a:xfrm>
+            <a:off x="548640" y="3291840"/>
+            <a:ext cx="2194560" cy="548640"/>
+          </a:xfrm>
+          <a:prstGeom prst="rect">
+            <a:avLst/>
+          </a:prstGeom>
+          <a:noFill/>
+          <a:ln/>
+        </p:spPr>
+        <p:txBody>
+          <a:bodyPr wrap="square" rtlCol="0" anchor="ctr"/>
+          <a:lstStyle/>
+          <a:p>
+            <a:pPr algn="ctr" indent="0" marL="0">
+              <a:buNone/>
+            </a:pPr>
+            <a:r>
+              <a:rPr lang="en-US" sz="1700" b="1" dirty="0">
+                <a:solidFill>
+                  <a:srgbClr val="FFFFFF"/>
+                </a:solidFill>
+                <a:latin typeface="Segoe UI" pitchFamily="34" charset="0"/>
+                <a:ea typeface="Segoe UI" pitchFamily="34" charset="-122"/>
+                <a:cs typeface="Segoe UI" pitchFamily="34" charset="-120"/>
+              </a:rPr>
+              <a:t>User Intervention</a:t>
+            </a:r>
+            <a:endParaRPr lang="en-US" sz="1700" dirty="0"/>
+          </a:p>
+        </p:txBody>
+      </p:sp>
+      <p:sp>
+        <p:nvSpPr>
+          <p:cNvPr id="17" name="Text 15"/>
+          <p:cNvSpPr/>
+          <p:nvPr/>
+        </p:nvSpPr>
+        <p:spPr>
+          <a:xfrm>
+            <a:off x="640080" y="3813048"/>
+            <a:ext cx="2011680" cy="640080"/>
+          </a:xfrm>
+          <a:prstGeom prst="rect">
+            <a:avLst/>
+          </a:prstGeom>
+          <a:noFill/>
+          <a:ln/>
+        </p:spPr>
+        <p:txBody>
+          <a:bodyPr wrap="square" rtlCol="0" anchor="ctr"/>
+          <a:lstStyle/>
+          <a:p>
+            <a:pPr algn="ctr" indent="0" marL="0">
+              <a:buNone/>
+            </a:pPr>
+            <a:r>
+              <a:rPr lang="en-US" sz="1050" i="1" dirty="0">
+                <a:solidFill>
+                  <a:srgbClr val="FFFFFF"/>
+                </a:solidFill>
+                <a:latin typeface="Segoe UI" pitchFamily="34" charset="0"/>
+                <a:ea typeface="Segoe UI" pitchFamily="34" charset="-122"/>
+                <a:cs typeface="Segoe UI" pitchFamily="34" charset="-120"/>
+              </a:rPr>
+              <a:t>The only manual touch-points — governance &amp; approval</a:t>
+            </a:r>
+            <a:endParaRPr lang="en-US" sz="1050" dirty="0"/>
+          </a:p>
+        </p:txBody>
+      </p:sp>
+      <p:sp>
+        <p:nvSpPr>
+          <p:cNvPr id="18" name="Shape 16"/>
+          <p:cNvSpPr/>
+          <p:nvPr/>
+        </p:nvSpPr>
+        <p:spPr>
+          <a:xfrm>
+            <a:off x="2880360" y="3154680"/>
+            <a:ext cx="8732520" cy="1371600"/>
+          </a:xfrm>
+          <a:prstGeom prst="roundRect">
+            <a:avLst>
+              <a:gd name="adj" fmla="val 5333"/>
+            </a:avLst>
+          </a:prstGeom>
+          <a:solidFill>
+            <a:srgbClr val="FFF3E0"/>
+          </a:solidFill>
+          <a:ln w="15875">
+            <a:solidFill>
+              <a:srgbClr val="E65100"/>
+            </a:solidFill>
+            <a:prstDash val="solid"/>
+          </a:ln>
+        </p:spPr>
+      </p:sp>
+      <p:sp>
+        <p:nvSpPr>
+          <p:cNvPr id="19" name="Shape 17"/>
+          <p:cNvSpPr/>
+          <p:nvPr/>
+        </p:nvSpPr>
+        <p:spPr>
+          <a:xfrm>
+            <a:off x="3017520" y="3429000"/>
+            <a:ext cx="3954780" cy="822960"/>
+          </a:xfrm>
+          <a:prstGeom prst="roundRect">
+            <a:avLst>
+              <a:gd name="adj" fmla="val 6667"/>
+            </a:avLst>
+          </a:prstGeom>
+          <a:solidFill>
+            <a:srgbClr val="FFFFFF"/>
+          </a:solidFill>
+          <a:ln w="12700">
+            <a:solidFill>
+              <a:srgbClr val="E65100"/>
+            </a:solidFill>
+            <a:prstDash val="solid"/>
+          </a:ln>
+        </p:spPr>
+      </p:sp>
+      <p:sp>
+        <p:nvSpPr>
+          <p:cNvPr id="20" name="Text 18"/>
+          <p:cNvSpPr/>
+          <p:nvPr/>
+        </p:nvSpPr>
+        <p:spPr>
+          <a:xfrm>
+            <a:off x="3063240" y="3429000"/>
+            <a:ext cx="3863340" cy="822960"/>
+          </a:xfrm>
+          <a:prstGeom prst="rect">
+            <a:avLst/>
+          </a:prstGeom>
+          <a:noFill/>
+          <a:ln/>
+        </p:spPr>
+        <p:txBody>
+          <a:bodyPr wrap="square" rtlCol="0" anchor="ctr"/>
+          <a:lstStyle/>
+          <a:p>
+            <a:pPr algn="ctr" indent="0" marL="0">
+              <a:buNone/>
+            </a:pPr>
+            <a:r>
+              <a:rPr lang="en-US" sz="1300" b="1" dirty="0">
+                <a:solidFill>
+                  <a:srgbClr val="1B1B2F"/>
+                </a:solidFill>
+                <a:latin typeface="Segoe UI" pitchFamily="34" charset="0"/>
+                <a:ea typeface="Segoe UI" pitchFamily="34" charset="-122"/>
+                <a:cs typeface="Segoe UI" pitchFamily="34" charset="-120"/>
+              </a:rPr>
+              <a:t>5. Review &amp; Decide</a:t>
+            </a:r>
+            <a:endParaRPr lang="en-US" sz="1300" dirty="0"/>
+          </a:p>
+        </p:txBody>
+      </p:sp>
+      <p:sp>
+        <p:nvSpPr>
+          <p:cNvPr id="21" name="Shape 19"/>
+          <p:cNvSpPr/>
+          <p:nvPr/>
+        </p:nvSpPr>
+        <p:spPr>
+          <a:xfrm>
+            <a:off x="7200900" y="3429000"/>
+            <a:ext cx="3954780" cy="822960"/>
+          </a:xfrm>
+          <a:prstGeom prst="roundRect">
+            <a:avLst>
+              <a:gd name="adj" fmla="val 6667"/>
+            </a:avLst>
+          </a:prstGeom>
+          <a:solidFill>
+            <a:srgbClr val="FFFFFF"/>
+          </a:solidFill>
+          <a:ln w="12700">
+            <a:solidFill>
+              <a:srgbClr val="E65100"/>
+            </a:solidFill>
+            <a:prstDash val="solid"/>
+          </a:ln>
+        </p:spPr>
+      </p:sp>
+      <p:sp>
+        <p:nvSpPr>
+          <p:cNvPr id="22" name="Text 20"/>
+          <p:cNvSpPr/>
+          <p:nvPr/>
+        </p:nvSpPr>
+        <p:spPr>
+          <a:xfrm>
+            <a:off x="7246620" y="3429000"/>
+            <a:ext cx="3863340" cy="822960"/>
+          </a:xfrm>
+          <a:prstGeom prst="rect">
+            <a:avLst/>
+          </a:prstGeom>
+          <a:noFill/>
+          <a:ln/>
+        </p:spPr>
+        <p:txBody>
+          <a:bodyPr wrap="square" rtlCol="0" anchor="ctr"/>
+          <a:lstStyle/>
+          <a:p>
+            <a:pPr algn="ctr" indent="0" marL="0">
+              <a:buNone/>
+            </a:pPr>
+            <a:r>
+              <a:rPr lang="en-US" sz="1300" b="1" dirty="0">
+                <a:solidFill>
+                  <a:srgbClr val="1B1B2F"/>
+                </a:solidFill>
+                <a:latin typeface="Segoe UI" pitchFamily="34" charset="0"/>
+                <a:ea typeface="Segoe UI" pitchFamily="34" charset="-122"/>
+                <a:cs typeface="Segoe UI" pitchFamily="34" charset="-120"/>
+              </a:rPr>
+              <a:t>6. Approve Rollback (1 click)</a:t>
+            </a:r>
+            <a:endParaRPr lang="en-US" sz="1300" dirty="0"/>
+          </a:p>
+        </p:txBody>
+      </p:sp>
+      <p:sp>
+        <p:nvSpPr>
+          <p:cNvPr id="23" name="Shape 21"/>
+          <p:cNvSpPr/>
+          <p:nvPr/>
+        </p:nvSpPr>
+        <p:spPr>
+          <a:xfrm>
+            <a:off x="548640" y="4709160"/>
+            <a:ext cx="2194560" cy="1371600"/>
+          </a:xfrm>
+          <a:prstGeom prst="roundRect">
+            <a:avLst>
+              <a:gd name="adj" fmla="val 5333"/>
+            </a:avLst>
+          </a:prstGeom>
+          <a:solidFill>
+            <a:srgbClr val="0D47A1"/>
+          </a:solidFill>
+          <a:ln/>
+        </p:spPr>
+      </p:sp>
+      <p:sp>
+        <p:nvSpPr>
+          <p:cNvPr id="24" name="Text 22"/>
+          <p:cNvSpPr/>
+          <p:nvPr/>
+        </p:nvSpPr>
+        <p:spPr>
+          <a:xfrm>
+            <a:off x="548640" y="4846320"/>
+            <a:ext cx="2194560" cy="548640"/>
+          </a:xfrm>
+          <a:prstGeom prst="rect">
+            <a:avLst/>
+          </a:prstGeom>
+          <a:noFill/>
+          <a:ln/>
+        </p:spPr>
+        <p:txBody>
+          <a:bodyPr wrap="square" rtlCol="0" anchor="ctr"/>
+          <a:lstStyle/>
+          <a:p>
+            <a:pPr algn="ctr" indent="0" marL="0">
+              <a:buNone/>
+            </a:pPr>
+            <a:r>
+              <a:rPr lang="en-US" sz="1700" b="1" dirty="0">
+                <a:solidFill>
+                  <a:srgbClr val="FFFFFF"/>
+                </a:solidFill>
+                <a:latin typeface="Segoe UI" pitchFamily="34" charset="0"/>
+                <a:ea typeface="Segoe UI" pitchFamily="34" charset="-122"/>
+                <a:cs typeface="Segoe UI" pitchFamily="34" charset="-120"/>
+              </a:rPr>
+              <a:t>Automated</a:t>
+            </a:r>
+            <a:endParaRPr lang="en-US" sz="1700" dirty="0"/>
+          </a:p>
+        </p:txBody>
+      </p:sp>
+      <p:sp>
+        <p:nvSpPr>
+          <p:cNvPr id="25" name="Text 23"/>
+          <p:cNvSpPr/>
+          <p:nvPr/>
+        </p:nvSpPr>
+        <p:spPr>
+          <a:xfrm>
+            <a:off x="640080" y="5367528"/>
+            <a:ext cx="2011680" cy="640080"/>
+          </a:xfrm>
+          <a:prstGeom prst="rect">
+            <a:avLst/>
+          </a:prstGeom>
+          <a:noFill/>
+          <a:ln/>
+        </p:spPr>
+        <p:txBody>
+          <a:bodyPr wrap="square" rtlCol="0" anchor="ctr"/>
+          <a:lstStyle/>
+          <a:p>
+            <a:pPr algn="ctr" indent="0" marL="0">
+              <a:buNone/>
+            </a:pPr>
+            <a:r>
+              <a:rPr lang="en-US" sz="1050" i="1" dirty="0">
+                <a:solidFill>
+                  <a:srgbClr val="FFFFFF"/>
+                </a:solidFill>
+                <a:latin typeface="Segoe UI" pitchFamily="34" charset="0"/>
+                <a:ea typeface="Segoe UI" pitchFamily="34" charset="-122"/>
+                <a:cs typeface="Segoe UI" pitchFamily="34" charset="-120"/>
+              </a:rPr>
+              <a:t>Executes &amp; records — zero scripting</a:t>
+            </a:r>
+            <a:endParaRPr lang="en-US" sz="1050" dirty="0"/>
+          </a:p>
+        </p:txBody>
+      </p:sp>
+      <p:sp>
+        <p:nvSpPr>
+          <p:cNvPr id="26" name="Shape 24"/>
+          <p:cNvSpPr/>
+          <p:nvPr/>
+        </p:nvSpPr>
+        <p:spPr>
+          <a:xfrm>
+            <a:off x="2880360" y="4709160"/>
+            <a:ext cx="8732520" cy="1371600"/>
+          </a:xfrm>
+          <a:prstGeom prst="roundRect">
+            <a:avLst>
+              <a:gd name="adj" fmla="val 5333"/>
+            </a:avLst>
+          </a:prstGeom>
+          <a:solidFill>
+            <a:srgbClr val="E1F0FF"/>
+          </a:solidFill>
+          <a:ln w="15875">
+            <a:solidFill>
+              <a:srgbClr val="0D47A1"/>
+            </a:solidFill>
+            <a:prstDash val="solid"/>
+          </a:ln>
+        </p:spPr>
+      </p:sp>
+      <p:sp>
+        <p:nvSpPr>
+          <p:cNvPr id="27" name="Shape 25"/>
+          <p:cNvSpPr/>
+          <p:nvPr/>
+        </p:nvSpPr>
+        <p:spPr>
+          <a:xfrm>
+            <a:off x="3017520" y="4983480"/>
+            <a:ext cx="2560320" cy="822960"/>
+          </a:xfrm>
+          <a:prstGeom prst="roundRect">
+            <a:avLst>
+              <a:gd name="adj" fmla="val 6667"/>
+            </a:avLst>
+          </a:prstGeom>
+          <a:solidFill>
+            <a:srgbClr val="FFFFFF"/>
+          </a:solidFill>
+          <a:ln w="12700">
+            <a:solidFill>
+              <a:srgbClr val="0D47A1"/>
+            </a:solidFill>
+            <a:prstDash val="solid"/>
+          </a:ln>
+        </p:spPr>
+      </p:sp>
+      <p:sp>
+        <p:nvSpPr>
+          <p:cNvPr id="28" name="Text 26"/>
+          <p:cNvSpPr/>
+          <p:nvPr/>
+        </p:nvSpPr>
+        <p:spPr>
+          <a:xfrm>
+            <a:off x="3063240" y="4983480"/>
+            <a:ext cx="2468880" cy="822960"/>
+          </a:xfrm>
+          <a:prstGeom prst="rect">
+            <a:avLst/>
+          </a:prstGeom>
+          <a:noFill/>
+          <a:ln/>
+        </p:spPr>
+        <p:txBody>
+          <a:bodyPr wrap="square" rtlCol="0" anchor="ctr"/>
+          <a:lstStyle/>
+          <a:p>
+            <a:pPr algn="ctr" indent="0" marL="0">
+              <a:buNone/>
+            </a:pPr>
+            <a:r>
+              <a:rPr lang="en-US" sz="1300" b="1" dirty="0">
+                <a:solidFill>
+                  <a:srgbClr val="1B1B2F"/>
+                </a:solidFill>
+                <a:latin typeface="Segoe UI" pitchFamily="34" charset="0"/>
+                <a:ea typeface="Segoe UI" pitchFamily="34" charset="-122"/>
+                <a:cs typeface="Segoe UI" pitchFamily="34" charset="-120"/>
+              </a:rPr>
+              <a:t>1. Baseline Capture</a:t>
+            </a:r>
+            <a:endParaRPr lang="en-US" sz="1300" dirty="0"/>
+          </a:p>
+        </p:txBody>
+      </p:sp>
+      <p:sp>
+        <p:nvSpPr>
+          <p:cNvPr id="29" name="Shape 27"/>
+          <p:cNvSpPr/>
+          <p:nvPr/>
+        </p:nvSpPr>
+        <p:spPr>
+          <a:xfrm>
+            <a:off x="5806440" y="4983480"/>
+            <a:ext cx="2560320" cy="822960"/>
+          </a:xfrm>
+          <a:prstGeom prst="roundRect">
+            <a:avLst>
+              <a:gd name="adj" fmla="val 6667"/>
+            </a:avLst>
+          </a:prstGeom>
+          <a:solidFill>
+            <a:srgbClr val="FFFFFF"/>
+          </a:solidFill>
+          <a:ln w="12700">
+            <a:solidFill>
+              <a:srgbClr val="0D47A1"/>
+            </a:solidFill>
+            <a:prstDash val="solid"/>
+          </a:ln>
+        </p:spPr>
+      </p:sp>
+      <p:sp>
+        <p:nvSpPr>
+          <p:cNvPr id="30" name="Text 28"/>
+          <p:cNvSpPr/>
+          <p:nvPr/>
+        </p:nvSpPr>
+        <p:spPr>
+          <a:xfrm>
+            <a:off x="5852160" y="4983480"/>
+            <a:ext cx="2468880" cy="822960"/>
+          </a:xfrm>
+          <a:prstGeom prst="rect">
+            <a:avLst/>
+          </a:prstGeom>
+          <a:noFill/>
+          <a:ln/>
+        </p:spPr>
+        <p:txBody>
+          <a:bodyPr wrap="square" rtlCol="0" anchor="ctr"/>
+          <a:lstStyle/>
+          <a:p>
+            <a:pPr algn="ctr" indent="0" marL="0">
+              <a:buNone/>
+            </a:pPr>
+            <a:r>
+              <a:rPr lang="en-US" sz="1300" b="1" dirty="0">
+                <a:solidFill>
+                  <a:srgbClr val="1B1B2F"/>
+                </a:solidFill>
+                <a:latin typeface="Segoe UI" pitchFamily="34" charset="0"/>
+                <a:ea typeface="Segoe UI" pitchFamily="34" charset="-122"/>
+                <a:cs typeface="Segoe UI" pitchFamily="34" charset="-120"/>
+              </a:rPr>
+              <a:t>7. Patch + Rolling Restart</a:t>
+            </a:r>
+            <a:endParaRPr lang="en-US" sz="1300" dirty="0"/>
+          </a:p>
+        </p:txBody>
+      </p:sp>
+      <p:sp>
+        <p:nvSpPr>
+          <p:cNvPr id="31" name="Shape 29"/>
+          <p:cNvSpPr/>
+          <p:nvPr/>
+        </p:nvSpPr>
+        <p:spPr>
+          <a:xfrm>
+            <a:off x="8595360" y="4983480"/>
+            <a:ext cx="2560320" cy="822960"/>
+          </a:xfrm>
+          <a:prstGeom prst="roundRect">
+            <a:avLst>
+              <a:gd name="adj" fmla="val 6667"/>
+            </a:avLst>
+          </a:prstGeom>
+          <a:solidFill>
+            <a:srgbClr val="FFFFFF"/>
+          </a:solidFill>
+          <a:ln w="12700">
+            <a:solidFill>
+              <a:srgbClr val="0D47A1"/>
+            </a:solidFill>
+            <a:prstDash val="solid"/>
+          </a:ln>
+        </p:spPr>
+      </p:sp>
+      <p:sp>
+        <p:nvSpPr>
+          <p:cNvPr id="32" name="Text 30"/>
+          <p:cNvSpPr/>
+          <p:nvPr/>
+        </p:nvSpPr>
+        <p:spPr>
+          <a:xfrm>
+            <a:off x="8641080" y="4983480"/>
+            <a:ext cx="2468880" cy="822960"/>
+          </a:xfrm>
+          <a:prstGeom prst="rect">
+            <a:avLst/>
+          </a:prstGeom>
+          <a:noFill/>
+          <a:ln/>
+        </p:spPr>
+        <p:txBody>
+          <a:bodyPr wrap="square" rtlCol="0" anchor="ctr"/>
+          <a:lstStyle/>
+          <a:p>
+            <a:pPr algn="ctr" indent="0" marL="0">
+              <a:buNone/>
+            </a:pPr>
+            <a:r>
+              <a:rPr lang="en-US" sz="1300" b="1" dirty="0">
+                <a:solidFill>
+                  <a:srgbClr val="1B1B2F"/>
+                </a:solidFill>
+                <a:latin typeface="Segoe UI" pitchFamily="34" charset="0"/>
+                <a:ea typeface="Segoe UI" pitchFamily="34" charset="-122"/>
+                <a:cs typeface="Segoe UI" pitchFamily="34" charset="-120"/>
+              </a:rPr>
+              <a:t>8. Verify &amp; Audit Log</a:t>
+            </a:r>
+            <a:endParaRPr lang="en-US" sz="1300" dirty="0"/>
+          </a:p>
+        </p:txBody>
+      </p:sp>
+      <p:sp>
+        <p:nvSpPr>
+          <p:cNvPr id="33" name="Text 31"/>
+          <p:cNvSpPr/>
+          <p:nvPr/>
+        </p:nvSpPr>
+        <p:spPr>
+          <a:xfrm>
+            <a:off x="548640" y="5943600"/>
+            <a:ext cx="11064240" cy="365760"/>
+          </a:xfrm>
+          <a:prstGeom prst="rect">
+            <a:avLst/>
+          </a:prstGeom>
+          <a:noFill/>
+          <a:ln/>
+        </p:spPr>
+        <p:txBody>
+          <a:bodyPr wrap="square" rtlCol="0" anchor="ctr"/>
+          <a:lstStyle/>
+          <a:p>
+            <a:pPr algn="ctr" indent="0" marL="0">
+              <a:buNone/>
+            </a:pPr>
+            <a:r>
+              <a:rPr lang="en-US" sz="1400" b="1" dirty="0">
+                <a:solidFill>
+                  <a:srgbClr val="1A237E"/>
+                </a:solidFill>
+                <a:latin typeface="Segoe UI" pitchFamily="34" charset="0"/>
+                <a:ea typeface="Segoe UI" pitchFamily="34" charset="-122"/>
+                <a:cs typeface="Segoe UI" pitchFamily="34" charset="-120"/>
+              </a:rPr>
+              <a:t>6 of 8 steps are fully autonomous. The user touches just 2 — review &amp; one-click approval.</a:t>
+            </a:r>
+            <a:endParaRPr lang="en-US" sz="1400" dirty="0"/>
+          </a:p>
+        </p:txBody>
+      </p:sp>
+    </p:spTree>
+  </p:cSld>
+  <p:clrMapOvr>
+    <a:masterClrMapping/>
+  </p:clrMapOvr>
+</p:sld>
+</file>
+
+<file path=ppt/slides/slide6.xml><?xml version="1.0" encoding="utf-8"?>
+<p:sld xmlns:a="http://schemas.openxmlformats.org/drawingml/2006/main" xmlns:r="http://schemas.openxmlformats.org/officeDocument/2006/relationships" xmlns:p="http://schemas.openxmlformats.org/presentationml/2006/main">
+  <p:cSld name="Slide 6">
+    <p:spTree>
+      <p:nvGrpSpPr>
+        <p:cNvPr id="1" name=""/>
+        <p:cNvGrpSpPr/>
+        <p:nvPr/>
+      </p:nvGrpSpPr>
+      <p:grpSpPr>
+        <a:xfrm>
+          <a:off x="0" y="0"/>
+          <a:ext cx="0" cy="0"/>
+          <a:chOff x="0" y="0"/>
+          <a:chExt cx="0" cy="0"/>
+        </a:xfrm>
+      </p:grpSpPr>
+      <p:sp>
+        <p:nvSpPr>
+          <p:cNvPr id="2" name="Shape 0"/>
+          <p:cNvSpPr/>
+          <p:nvPr/>
+        </p:nvSpPr>
+        <p:spPr>
+          <a:xfrm>
+            <a:off x="0" y="0"/>
+            <a:ext cx="228600" cy="6858000"/>
+          </a:xfrm>
+          <a:prstGeom prst="rect">
+            <a:avLst/>
+          </a:prstGeom>
+          <a:solidFill>
+            <a:srgbClr val="E65100"/>
+          </a:solidFill>
+          <a:ln/>
+        </p:spPr>
+      </p:sp>
+      <p:sp>
+        <p:nvSpPr>
           <p:cNvPr id="3" name="Text 1"/>
           <p:cNvSpPr/>
           <p:nvPr/>
         </p:nvSpPr>
         <p:spPr>
           <a:xfrm>
-            <a:off x="548640" y="320040"/>
+            <a:off x="548640" y="292608"/>
             <a:ext cx="10058400" cy="320040"/>
           </a:xfrm>
           <a:prstGeom prst="rect">
@@ -4236,8 +6913,8 @@
         </p:nvSpPr>
         <p:spPr>
           <a:xfrm>
-            <a:off x="548640" y="640080"/>
-            <a:ext cx="10972800" cy="731520"/>
+            <a:off x="548640" y="603504"/>
+            <a:ext cx="10972800" cy="640080"/>
           </a:xfrm>
           <a:prstGeom prst="rect">
             <a:avLst/>
@@ -4253,7 +6930,7 @@
               <a:buNone/>
             </a:pPr>
             <a:r>
-              <a:rPr lang="en-US" sz="2800" b="1" dirty="0">
+              <a:rPr lang="en-US" sz="2700" b="1" dirty="0">
                 <a:solidFill>
                   <a:srgbClr val="1B1B2F"/>
                 </a:solidFill>
@@ -4263,13 +6940,13 @@
               </a:rPr>
               <a:t>Manual SRE vs AI Agent — per drift event</a:t>
             </a:r>
-            <a:endParaRPr lang="en-US" sz="2800" dirty="0"/>
+            <a:endParaRPr lang="en-US" sz="2700" dirty="0"/>
           </a:p>
         </p:txBody>
       </p:sp>
       <p:graphicFrame>
         <p:nvGraphicFramePr>
-          <p:cNvPr id="6" name="Table 0"/>
+          <p:cNvPr id="7" name="Table 0"/>
           <p:cNvGraphicFramePr>
             <a:graphicFrameLocks noGrp="1"/>
           </p:cNvGraphicFramePr>
@@ -4282,7 +6959,7 @@
           </p:nvPr>
         </p:nvGraphicFramePr>
         <p:xfrm>
-          <a:off x="548640" y="1554480"/>
+          <a:off x="548640" y="1463040"/>
           <a:ext cx="11064240" cy="914400"/>
         </p:xfrm>
         <a:graphic>
@@ -4296,13 +6973,13 @@
                 <a:gridCol w="3566160"/>
                 <a:gridCol w="731520"/>
               </a:tblGrid>
-              <a:tr h="457200">
+              <a:tr h="475488">
                 <a:tc>
                   <a:txBody>
                     <a:bodyPr/>
                     <a:lstStyle/>
                     <a:p>
-                      <a:pPr algn="l" indent="0" marL="0">
+                      <a:pPr indent="0" marL="0">
                         <a:buNone/>
                       </a:pPr>
                       <a:r>
@@ -4370,7 +7047,7 @@
                     <a:bodyPr/>
                     <a:lstStyle/>
                     <a:p>
-                      <a:pPr algn="l" indent="0" marL="0">
+                      <a:pPr indent="0" marL="0">
                         <a:buNone/>
                       </a:pPr>
                       <a:r>
@@ -4506,7 +7183,7 @@
                     <a:bodyPr/>
                     <a:lstStyle/>
                     <a:p>
-                      <a:pPr algn="l" indent="0" marL="0">
+                      <a:pPr indent="0" marL="0">
                         <a:buNone/>
                       </a:pPr>
                       <a:r>
@@ -4638,13 +7315,13 @@
                   </a:tcPr>
                 </a:tc>
               </a:tr>
-              <a:tr h="457200">
+              <a:tr h="475488">
                 <a:tc>
                   <a:txBody>
                     <a:bodyPr/>
                     <a:lstStyle/>
                     <a:p>
-                      <a:pPr algn="l" indent="0" marL="0">
+                      <a:pPr indent="0" marL="0">
                         <a:buNone/>
                       </a:pPr>
                       <a:r>
@@ -4709,13 +7386,13 @@
                     <a:bodyPr/>
                     <a:lstStyle/>
                     <a:p>
-                      <a:pPr algn="l" indent="0" marL="0">
+                      <a:pPr indent="0" marL="0">
                         <a:buNone/>
                       </a:pPr>
                       <a:r>
                         <a:rPr lang="en-US" sz="1200" dirty="0">
                           <a:solidFill>
-                            <a:srgbClr val="000000"/>
+                            <a:srgbClr val="1B1B2F"/>
                           </a:solidFill>
                           <a:latin typeface="Segoe UI" pitchFamily="34" charset="0"/>
                           <a:ea typeface="Segoe UI" pitchFamily="34" charset="-122"/>
@@ -4839,13 +7516,13 @@
                     <a:bodyPr/>
                     <a:lstStyle/>
                     <a:p>
-                      <a:pPr algn="l" indent="0" marL="0">
+                      <a:pPr indent="0" marL="0">
                         <a:buNone/>
                       </a:pPr>
                       <a:r>
                         <a:rPr lang="en-US" sz="1200" dirty="0">
                           <a:solidFill>
-                            <a:srgbClr val="000000"/>
+                            <a:srgbClr val="1B1B2F"/>
                           </a:solidFill>
                           <a:latin typeface="Segoe UI" pitchFamily="34" charset="0"/>
                           <a:ea typeface="Segoe UI" pitchFamily="34" charset="-122"/>
@@ -4965,13 +7642,13 @@
                   </a:tcPr>
                 </a:tc>
               </a:tr>
-              <a:tr h="457200">
+              <a:tr h="475488">
                 <a:tc>
                   <a:txBody>
                     <a:bodyPr/>
                     <a:lstStyle/>
                     <a:p>
-                      <a:pPr algn="l" indent="0" marL="0">
+                      <a:pPr indent="0" marL="0">
                         <a:buNone/>
                       </a:pPr>
                       <a:r>
@@ -5039,13 +7716,13 @@
                     <a:bodyPr/>
                     <a:lstStyle/>
                     <a:p>
-                      <a:pPr algn="l" indent="0" marL="0">
+                      <a:pPr indent="0" marL="0">
                         <a:buNone/>
                       </a:pPr>
                       <a:r>
                         <a:rPr lang="en-US" sz="1200" dirty="0">
                           <a:solidFill>
-                            <a:srgbClr val="000000"/>
+                            <a:srgbClr val="1B1B2F"/>
                           </a:solidFill>
                           <a:latin typeface="Segoe UI" pitchFamily="34" charset="0"/>
                           <a:ea typeface="Segoe UI" pitchFamily="34" charset="-122"/>
@@ -5175,13 +7852,13 @@
                     <a:bodyPr/>
                     <a:lstStyle/>
                     <a:p>
-                      <a:pPr algn="l" indent="0" marL="0">
+                      <a:pPr indent="0" marL="0">
                         <a:buNone/>
                       </a:pPr>
                       <a:r>
                         <a:rPr lang="en-US" sz="1200" dirty="0">
                           <a:solidFill>
-                            <a:srgbClr val="000000"/>
+                            <a:srgbClr val="1B1B2F"/>
                           </a:solidFill>
                           <a:latin typeface="Segoe UI" pitchFamily="34" charset="0"/>
                           <a:ea typeface="Segoe UI" pitchFamily="34" charset="-122"/>
@@ -5307,13 +7984,13 @@
                   </a:tcPr>
                 </a:tc>
               </a:tr>
-              <a:tr h="457200">
+              <a:tr h="475488">
                 <a:tc>
                   <a:txBody>
                     <a:bodyPr/>
                     <a:lstStyle/>
                     <a:p>
-                      <a:pPr algn="l" indent="0" marL="0">
+                      <a:pPr indent="0" marL="0">
                         <a:buNone/>
                       </a:pPr>
                       <a:r>
@@ -5378,13 +8055,13 @@
                     <a:bodyPr/>
                     <a:lstStyle/>
                     <a:p>
-                      <a:pPr algn="l" indent="0" marL="0">
+                      <a:pPr indent="0" marL="0">
                         <a:buNone/>
                       </a:pPr>
                       <a:r>
                         <a:rPr lang="en-US" sz="1200" dirty="0">
                           <a:solidFill>
-                            <a:srgbClr val="000000"/>
+                            <a:srgbClr val="1B1B2F"/>
                           </a:solidFill>
                           <a:latin typeface="Segoe UI" pitchFamily="34" charset="0"/>
                           <a:ea typeface="Segoe UI" pitchFamily="34" charset="-122"/>
@@ -5508,13 +8185,13 @@
                     <a:bodyPr/>
                     <a:lstStyle/>
                     <a:p>
-                      <a:pPr algn="l" indent="0" marL="0">
+                      <a:pPr indent="0" marL="0">
                         <a:buNone/>
                       </a:pPr>
                       <a:r>
                         <a:rPr lang="en-US" sz="1200" dirty="0">
                           <a:solidFill>
-                            <a:srgbClr val="000000"/>
+                            <a:srgbClr val="1B1B2F"/>
                           </a:solidFill>
                           <a:latin typeface="Segoe UI" pitchFamily="34" charset="0"/>
                           <a:ea typeface="Segoe UI" pitchFamily="34" charset="-122"/>
@@ -5634,13 +8311,13 @@
                   </a:tcPr>
                 </a:tc>
               </a:tr>
-              <a:tr h="457200">
+              <a:tr h="475488">
                 <a:tc>
                   <a:txBody>
                     <a:bodyPr/>
                     <a:lstStyle/>
                     <a:p>
-                      <a:pPr algn="l" indent="0" marL="0">
+                      <a:pPr indent="0" marL="0">
                         <a:buNone/>
                       </a:pPr>
                       <a:r>
@@ -5708,13 +8385,13 @@
                     <a:bodyPr/>
                     <a:lstStyle/>
                     <a:p>
-                      <a:pPr algn="l" indent="0" marL="0">
+                      <a:pPr indent="0" marL="0">
                         <a:buNone/>
                       </a:pPr>
                       <a:r>
                         <a:rPr lang="en-US" sz="1200" dirty="0">
                           <a:solidFill>
-                            <a:srgbClr val="000000"/>
+                            <a:srgbClr val="1B1B2F"/>
                           </a:solidFill>
                           <a:latin typeface="Segoe UI" pitchFamily="34" charset="0"/>
                           <a:ea typeface="Segoe UI" pitchFamily="34" charset="-122"/>
@@ -5844,13 +8521,13 @@
                     <a:bodyPr/>
                     <a:lstStyle/>
                     <a:p>
-                      <a:pPr algn="l" indent="0" marL="0">
+                      <a:pPr indent="0" marL="0">
                         <a:buNone/>
                       </a:pPr>
                       <a:r>
                         <a:rPr lang="en-US" sz="1200" dirty="0">
                           <a:solidFill>
-                            <a:srgbClr val="000000"/>
+                            <a:srgbClr val="1B1B2F"/>
                           </a:solidFill>
                           <a:latin typeface="Segoe UI" pitchFamily="34" charset="0"/>
                           <a:ea typeface="Segoe UI" pitchFamily="34" charset="-122"/>
@@ -5976,13 +8653,13 @@
                   </a:tcPr>
                 </a:tc>
               </a:tr>
-              <a:tr h="457200">
+              <a:tr h="475488">
                 <a:tc>
                   <a:txBody>
                     <a:bodyPr/>
                     <a:lstStyle/>
                     <a:p>
-                      <a:pPr algn="l" indent="0" marL="0">
+                      <a:pPr indent="0" marL="0">
                         <a:buNone/>
                       </a:pPr>
                       <a:r>
@@ -6047,13 +8724,13 @@
                     <a:bodyPr/>
                     <a:lstStyle/>
                     <a:p>
-                      <a:pPr algn="l" indent="0" marL="0">
+                      <a:pPr indent="0" marL="0">
                         <a:buNone/>
                       </a:pPr>
                       <a:r>
                         <a:rPr lang="en-US" sz="1200" dirty="0">
                           <a:solidFill>
-                            <a:srgbClr val="000000"/>
+                            <a:srgbClr val="1B1B2F"/>
                           </a:solidFill>
                           <a:latin typeface="Segoe UI" pitchFamily="34" charset="0"/>
                           <a:ea typeface="Segoe UI" pitchFamily="34" charset="-122"/>
@@ -6177,13 +8854,13 @@
                     <a:bodyPr/>
                     <a:lstStyle/>
                     <a:p>
-                      <a:pPr algn="l" indent="0" marL="0">
+                      <a:pPr indent="0" marL="0">
                         <a:buNone/>
                       </a:pPr>
                       <a:r>
                         <a:rPr lang="en-US" sz="1200" dirty="0">
                           <a:solidFill>
-                            <a:srgbClr val="000000"/>
+                            <a:srgbClr val="1B1B2F"/>
                           </a:solidFill>
                           <a:latin typeface="Segoe UI" pitchFamily="34" charset="0"/>
                           <a:ea typeface="Segoe UI" pitchFamily="34" charset="-122"/>
@@ -6303,13 +8980,13 @@
                   </a:tcPr>
                 </a:tc>
               </a:tr>
-              <a:tr h="457200">
+              <a:tr h="475488">
                 <a:tc>
                   <a:txBody>
                     <a:bodyPr/>
                     <a:lstStyle/>
                     <a:p>
-                      <a:pPr algn="l" indent="0" marL="0">
+                      <a:pPr indent="0" marL="0">
                         <a:buNone/>
                       </a:pPr>
                       <a:r>
@@ -6377,13 +9054,13 @@
                     <a:bodyPr/>
                     <a:lstStyle/>
                     <a:p>
-                      <a:pPr algn="l" indent="0" marL="0">
+                      <a:pPr indent="0" marL="0">
                         <a:buNone/>
                       </a:pPr>
                       <a:r>
                         <a:rPr lang="en-US" sz="1200" dirty="0">
                           <a:solidFill>
-                            <a:srgbClr val="000000"/>
+                            <a:srgbClr val="1B1B2F"/>
                           </a:solidFill>
                           <a:latin typeface="Segoe UI" pitchFamily="34" charset="0"/>
                           <a:ea typeface="Segoe UI" pitchFamily="34" charset="-122"/>
@@ -6513,13 +9190,13 @@
                     <a:bodyPr/>
                     <a:lstStyle/>
                     <a:p>
-                      <a:pPr algn="l" indent="0" marL="0">
+                      <a:pPr indent="0" marL="0">
                         <a:buNone/>
                       </a:pPr>
                       <a:r>
                         <a:rPr lang="en-US" sz="1200" dirty="0">
                           <a:solidFill>
-                            <a:srgbClr val="000000"/>
+                            <a:srgbClr val="1B1B2F"/>
                           </a:solidFill>
                           <a:latin typeface="Segoe UI" pitchFamily="34" charset="0"/>
                           <a:ea typeface="Segoe UI" pitchFamily="34" charset="-122"/>
@@ -6657,12 +9334,12 @@
         </p:nvSpPr>
         <p:spPr>
           <a:xfrm>
-            <a:off x="548640" y="5394960"/>
-            <a:ext cx="5394960" cy="777240"/>
+            <a:off x="548640" y="5440680"/>
+            <a:ext cx="5394960" cy="749808"/>
           </a:xfrm>
           <a:prstGeom prst="roundRect">
             <a:avLst>
-              <a:gd name="adj" fmla="val 9412"/>
+              <a:gd name="adj" fmla="val 9756"/>
             </a:avLst>
           </a:prstGeom>
           <a:solidFill>
@@ -6679,8 +9356,8 @@
         </p:nvSpPr>
         <p:spPr>
           <a:xfrm>
-            <a:off x="548640" y="5394960"/>
-            <a:ext cx="5394960" cy="777240"/>
+            <a:off x="548640" y="5440680"/>
+            <a:ext cx="5394960" cy="749808"/>
           </a:xfrm>
           <a:prstGeom prst="rect">
             <a:avLst/>
@@ -6733,12 +9410,12 @@
         </p:nvSpPr>
         <p:spPr>
           <a:xfrm>
-            <a:off x="6217920" y="5394960"/>
-            <a:ext cx="5394960" cy="777240"/>
+            <a:off x="6217920" y="5440680"/>
+            <a:ext cx="5394960" cy="749808"/>
           </a:xfrm>
           <a:prstGeom prst="roundRect">
             <a:avLst>
-              <a:gd name="adj" fmla="val 9412"/>
+              <a:gd name="adj" fmla="val 9756"/>
             </a:avLst>
           </a:prstGeom>
           <a:solidFill>
@@ -6755,8 +9432,8 @@
         </p:nvSpPr>
         <p:spPr>
           <a:xfrm>
-            <a:off x="6217920" y="5394960"/>
-            <a:ext cx="5394960" cy="777240"/>
+            <a:off x="6217920" y="5440680"/>
+            <a:ext cx="5394960" cy="749808"/>
           </a:xfrm>
           <a:prstGeom prst="rect">
             <a:avLst/>
@@ -6809,9 +9486,9 @@
 </p:sld>
 </file>
 
-<file path=ppt/slides/slide6.xml><?xml version="1.0" encoding="utf-8"?>
+<file path=ppt/slides/slide7.xml><?xml version="1.0" encoding="utf-8"?>
 <p:sld xmlns:a="http://schemas.openxmlformats.org/drawingml/2006/main" xmlns:r="http://schemas.openxmlformats.org/officeDocument/2006/relationships" xmlns:p="http://schemas.openxmlformats.org/presentationml/2006/main">
-  <p:cSld name="Slide 6">
+  <p:cSld name="Slide 7">
     <p:spTree>
       <p:nvGrpSpPr>
         <p:cNvPr id="1" name=""/>
@@ -6854,7 +9531,7 @@
         </p:nvSpPr>
         <p:spPr>
           <a:xfrm>
-            <a:off x="548640" y="320040"/>
+            <a:off x="548640" y="292608"/>
             <a:ext cx="10058400" cy="320040"/>
           </a:xfrm>
           <a:prstGeom prst="rect">
@@ -6893,8 +9570,8 @@
         </p:nvSpPr>
         <p:spPr>
           <a:xfrm>
-            <a:off x="548640" y="640080"/>
-            <a:ext cx="10972800" cy="731520"/>
+            <a:off x="548640" y="603504"/>
+            <a:ext cx="10972800" cy="640080"/>
           </a:xfrm>
           <a:prstGeom prst="rect">
             <a:avLst/>
@@ -6910,7 +9587,7 @@
               <a:buNone/>
             </a:pPr>
             <a:r>
-              <a:rPr lang="en-US" sz="2800" b="1" dirty="0">
+              <a:rPr lang="en-US" sz="2700" b="1" dirty="0">
                 <a:solidFill>
                   <a:srgbClr val="1B1B2F"/>
                 </a:solidFill>
@@ -6920,13 +9597,13 @@
               </a:rPr>
               <a:t>90-second walkthrough</a:t>
             </a:r>
-            <a:endParaRPr lang="en-US" sz="2800" dirty="0"/>
+            <a:endParaRPr lang="en-US" sz="2700" dirty="0"/>
           </a:p>
         </p:txBody>
       </p:sp>
       <p:graphicFrame>
         <p:nvGraphicFramePr>
-          <p:cNvPr id="7" name="Table 0"/>
+          <p:cNvPr id="8" name="Table 0"/>
           <p:cNvGraphicFramePr>
             <a:graphicFrameLocks noGrp="1"/>
           </p:cNvGraphicFramePr>
@@ -6939,7 +9616,7 @@
           </p:nvPr>
         </p:nvGraphicFramePr>
         <p:xfrm>
-          <a:off x="548640" y="1554480"/>
+          <a:off x="548640" y="1463040"/>
           <a:ext cx="11064240" cy="914400"/>
         </p:xfrm>
         <a:graphic>
@@ -8846,7 +11523,7 @@
         </p:nvSpPr>
         <p:spPr>
           <a:xfrm>
-            <a:off x="548640" y="5760720"/>
+            <a:off x="548640" y="5806440"/>
             <a:ext cx="11064240" cy="457200"/>
           </a:xfrm>
           <a:prstGeom prst="rect">
@@ -8885,9 +11562,9 @@
 </p:sld>
 </file>
 
-<file path=ppt/slides/slide7.xml><?xml version="1.0" encoding="utf-8"?>
+<file path=ppt/slides/slide8.xml><?xml version="1.0" encoding="utf-8"?>
 <p:sld xmlns:a="http://schemas.openxmlformats.org/drawingml/2006/main" xmlns:r="http://schemas.openxmlformats.org/officeDocument/2006/relationships" xmlns:p="http://schemas.openxmlformats.org/presentationml/2006/main">
-  <p:cSld name="Slide 7">
+  <p:cSld name="Slide 8">
     <p:spTree>
       <p:nvGrpSpPr>
         <p:cNvPr id="1" name=""/>
@@ -8930,7 +11607,7 @@
         </p:nvSpPr>
         <p:spPr>
           <a:xfrm>
-            <a:off x="548640" y="320040"/>
+            <a:off x="548640" y="292608"/>
             <a:ext cx="10058400" cy="320040"/>
           </a:xfrm>
           <a:prstGeom prst="rect">
@@ -8969,8 +11646,8 @@
         </p:nvSpPr>
         <p:spPr>
           <a:xfrm>
-            <a:off x="548640" y="640080"/>
-            <a:ext cx="10972800" cy="731520"/>
+            <a:off x="548640" y="603504"/>
+            <a:ext cx="10972800" cy="640080"/>
           </a:xfrm>
           <a:prstGeom prst="rect">
             <a:avLst/>
@@ -8986,7 +11663,7 @@
               <a:buNone/>
             </a:pPr>
             <a:r>
-              <a:rPr lang="en-US" sz="2800" b="1" dirty="0">
+              <a:rPr lang="en-US" sz="2700" b="1" dirty="0">
                 <a:solidFill>
                   <a:srgbClr val="1B1B2F"/>
                 </a:solidFill>
@@ -8996,7 +11673,7 @@
               </a:rPr>
               <a:t>The judges' takeaways</a:t>
             </a:r>
-            <a:endParaRPr lang="en-US" sz="2800" dirty="0"/>
+            <a:endParaRPr lang="en-US" sz="2700" dirty="0"/>
           </a:p>
         </p:txBody>
       </p:sp>
@@ -9122,7 +11799,7 @@
                 <a:ea typeface="Segoe UI" pitchFamily="34" charset="-122"/>
                 <a:cs typeface="Segoe UI" pitchFamily="34" charset="-120"/>
               </a:rPr>
-              <a:t>Self-healing infrastructure demonstrated against a REAL cluster — drift appears and is reverted in under a minute.</a:t>
+              <a:t>Self-healing demonstrated against a REAL cluster — drift appears and is reverted in under a minute.</a:t>
             </a:r>
             <a:endParaRPr lang="en-US" sz="1400" dirty="0"/>
           </a:p>
@@ -9250,7 +11927,7 @@
                 <a:ea typeface="Segoe UI" pitchFamily="34" charset="-122"/>
                 <a:cs typeface="Segoe UI" pitchFamily="34" charset="-120"/>
               </a:rPr>
-              <a:t>Most tools only alert. This one explains the drift in natural language AND remediates it with one click.</a:t>
+              <a:t>Most tools only alert. This one explains the drift in plain English AND remediates it with one click.</a:t>
             </a:r>
             <a:endParaRPr lang="en-US" sz="1400" dirty="0"/>
           </a:p>
@@ -9378,7 +12055,7 @@
                 <a:ea typeface="Segoe UI" pitchFamily="34" charset="-122"/>
                 <a:cs typeface="Segoe UI" pitchFamily="34" charset="-120"/>
               </a:rPr>
-              <a:t>Directly tackles GitOps governance, change management &amp; audit compliance — top concerns for regulated OpenShift buyers.</a:t>
+              <a:t>Tackles GitOps governance, change management &amp; audit compliance — top concerns for regulated buyers.</a:t>
             </a:r>
             <a:endParaRPr lang="en-US" sz="1400" dirty="0"/>
           </a:p>
@@ -9520,9 +12197,9 @@
 </p:sld>
 </file>
 
-<file path=ppt/slides/slide8.xml><?xml version="1.0" encoding="utf-8"?>
+<file path=ppt/slides/slide9.xml><?xml version="1.0" encoding="utf-8"?>
 <p:sld xmlns:a="http://schemas.openxmlformats.org/drawingml/2006/main" xmlns:r="http://schemas.openxmlformats.org/officeDocument/2006/relationships" xmlns:p="http://schemas.openxmlformats.org/presentationml/2006/main">
-  <p:cSld name="Slide 8">
+  <p:cSld name="Slide 9">
     <p:bg>
       <p:bgPr>
         <a:solidFill>
@@ -9608,7 +12285,27 @@
       </p:sp>
       <p:sp>
         <p:nvSpPr>
-          <p:cNvPr id="3" name="Text 1"/>
+          <p:cNvPr id="3" name="Shape 1"/>
+          <p:cNvSpPr/>
+          <p:nvPr/>
+        </p:nvSpPr>
+        <p:spPr>
+          <a:xfrm>
+            <a:off x="731520" y="4023360"/>
+            <a:ext cx="3200400" cy="54864"/>
+          </a:xfrm>
+          <a:prstGeom prst="rect">
+            <a:avLst/>
+          </a:prstGeom>
+          <a:solidFill>
+            <a:srgbClr val="00695C"/>
+          </a:solidFill>
+          <a:ln/>
+        </p:spPr>
+      </p:sp>
+      <p:sp>
+        <p:nvSpPr>
+          <p:cNvPr id="4" name="Text 2"/>
           <p:cNvSpPr/>
           <p:nvPr/>
         </p:nvSpPr>
@@ -9644,26 +12341,6 @@
             <a:endParaRPr lang="en-US" sz="2000" dirty="0"/>
           </a:p>
         </p:txBody>
-      </p:sp>
-      <p:sp>
-        <p:nvSpPr>
-          <p:cNvPr id="4" name="Shape 2"/>
-          <p:cNvSpPr/>
-          <p:nvPr/>
-        </p:nvSpPr>
-        <p:spPr>
-          <a:xfrm>
-            <a:off x="731520" y="4023360"/>
-            <a:ext cx="3200400" cy="54864"/>
-          </a:xfrm>
-          <a:prstGeom prst="rect">
-            <a:avLst/>
-          </a:prstGeom>
-          <a:solidFill>
-            <a:srgbClr val="00695C"/>
-          </a:solidFill>
-          <a:ln/>
-        </p:spPr>
       </p:sp>
     </p:spTree>
   </p:cSld>

</xml_diff>